<commit_message>
Generalize problem slide around legacy debt and compliance-driven upgrades
Co-Authored-By: Devin AI <158243242+devin-ai-integration[bot]@users.noreply.github.com>
</commit_message>
<xml_diff>
--- a/presentation/BofA_x_Cognition_Devin_Demo.pptx
+++ b/presentation/BofA_x_Cognition_Devin_Demo.pptx
@@ -1010,34 +1010,46 @@
           <a:lstStyle/>
           <a:p>
             <a:r>
-              <a:t>This is the most important non-demo slide. Spend real time here and let THEM correct you — being corrected is a win, it means engagement and better intel.</a:t>
+              <a:t>This is the most important non-demo slide. Keep it general — the specific Angular 14→18 story is the demo's job; here you're naming the pattern they live with every day.</a:t>
             </a:r>
           </a:p>
           <a:p/>
           <a:p>
             <a:r>
-              <a:t>Talk track: "Here's my understanding of what you're up against — please red-pen this. You have a hard, policy-driven deadline on an app you cannot afford to destabilize, and the thing that makes it slow isn't typing code, it's the coordination tax across a dozen consuming teams."</a:t>
+              <a:t>Talk track: "Here's the pattern I suspect you know well. Frameworks and platforms age out — Angular, Java versions, Spring, on-prem stacks — and your own security policy says unsupported software can't run in production. So upgrades arrive with hard compliance deadlines, they land on your most experienced engineers, and every one of them displaces greenfield work. The backlog doesn't shrink; it compounds. The cruel part: the better your engineers are, the more of them you burn on maintenance nobody will ever see."</a:t>
             </a:r>
           </a:p>
           <a:p/>
           <a:p>
             <a:r>
+              <a:t>Bridge to the demo (one line, don't dwell): "Today's concrete example is your Angular 14→18 migration — hard EOL deadline, millions of customers, a shared library with 12+ downstream teams. We'll dig into that live in the demo."</a:t>
+            </a:r>
+          </a:p>
+          <a:p/>
+          <a:p>
+            <a:r>
+              <a:t>Spend real time here and let THEM correct you — being corrected is a win, it means engagement and better intel.</a:t>
+            </a:r>
+          </a:p>
+          <a:p/>
+          <a:p>
+            <a:r>
               <a:t>[ASK, by persona]</a:t>
             </a:r>
           </a:p>
           <a:p>
             <a:r>
-              <a:t>- VP Eng: "What's the current internal estimate for the upgrade, and what's it displacing on the roadmap?"</a:t>
-            </a:r>
-          </a:p>
-          <a:p>
-            <a:r>
-              <a:t>- Security: "What does your policy actually require when a framework goes EOL — remediation plan? exception filing? What's your audit exposure today?"</a:t>
-            </a:r>
-          </a:p>
-          <a:p>
-            <a:r>
-              <a:t>- Architect: "How do downstream teams consume the library today — pinned versions? monorepo? That changes the rollout strategy."</a:t>
+              <a:t>- VP Eng: "How much of your team's capacity goes to maintenance and upgrades versus new build? What's the number you wish it was?"</a:t>
+            </a:r>
+          </a:p>
+          <a:p>
+            <a:r>
+              <a:t>- Security: "What does your policy actually require when something goes EOL — remediation plan? exception filing? What's your audit exposure today?"</a:t>
+            </a:r>
+          </a:p>
+          <a:p>
+            <a:r>
+              <a:t>- Architect: "Where's the next EOL clock ticking in your estate — and how does that upgrade propagate through shared dependencies?"</a:t>
             </a:r>
           </a:p>
           <a:p/>
@@ -7766,7 +7778,7 @@
                 </a:solidFill>
                 <a:latin typeface="Roboto"/>
               </a:rPr>
-              <a:t>Angular 14 EOL — you talk, I listen</a:t>
+              <a:t>Legacy debt, compliance clocks — you talk, I listen</a:t>
             </a:r>
           </a:p>
         </p:txBody>
@@ -8282,7 +8294,7 @@
                 </a:solidFill>
                 <a:latin typeface="Roboto"/>
               </a:rPr>
-              <a:t>The real 14→18 migration, live</a:t>
+              <a:t>A real framework migration, live</a:t>
             </a:r>
           </a:p>
         </p:txBody>
@@ -9072,7 +9084,7 @@
                 </a:solidFill>
                 <a:latin typeface="Roboto"/>
               </a:rPr>
-              <a:t>The problem: a compliance clock on a system that can't break</a:t>
+              <a:t>The problem: legacy debt is eating your roadmap</a:t>
             </a:r>
           </a:p>
         </p:txBody>
@@ -9156,7 +9168,7 @@
                 </a:solidFill>
                 <a:latin typeface="Roboto"/>
               </a:rPr>
-              <a:t>Angular 14 is past end-of-life </a:t>
+              <a:t>Frameworks age out </a:t>
             </a:r>
             <a:r>
               <a:rPr sz="1700" b="0" i="0">
@@ -9165,7 +9177,7 @@
                 </a:solidFill>
                 <a:latin typeface="Roboto"/>
               </a:rPr>
-              <a:t>— an EOL framework in production violates your own security policy.</a:t>
+              <a:t>— and running unsupported software in production violates your own security policy.</a:t>
             </a:r>
           </a:p>
         </p:txBody>
@@ -9297,7 +9309,7 @@
                 </a:solidFill>
                 <a:latin typeface="Roboto"/>
               </a:rPr>
-              <a:t>The blast radius</a:t>
+              <a:t>The debt</a:t>
             </a:r>
           </a:p>
         </p:txBody>
@@ -9339,7 +9351,7 @@
                 </a:solidFill>
                 <a:latin typeface="Roboto"/>
               </a:rPr>
-              <a:t>Millions of retail customers</a:t>
+              <a:t>Outdated frameworks across the estate</a:t>
             </a:r>
           </a:p>
           <a:p>
@@ -9358,7 +9370,7 @@
                 </a:solidFill>
                 <a:latin typeface="Roboto"/>
               </a:rPr>
-              <a:t>12+ downstream teams</a:t>
+              <a:t>Every deferred upgrade compounds</a:t>
             </a:r>
           </a:p>
         </p:txBody>
@@ -9490,7 +9502,7 @@
                 </a:solidFill>
                 <a:latin typeface="Roboto"/>
               </a:rPr>
-              <a:t>The complexity</a:t>
+              <a:t>The clock</a:t>
             </a:r>
           </a:p>
         </p:txBody>
@@ -9532,7 +9544,7 @@
                 </a:solidFill>
                 <a:latin typeface="Roboto"/>
               </a:rPr>
-              <a:t>SSO / MFA · analytics SDK</a:t>
+              <a:t>Compliance-driven EOL deadlines</a:t>
             </a:r>
           </a:p>
           <a:p>
@@ -9551,7 +9563,7 @@
                 </a:solidFill>
                 <a:latin typeface="Roboto"/>
               </a:rPr>
-              <a:t>Financial data providers</a:t>
+              <a:t>Audit exposure while you wait</a:t>
             </a:r>
           </a:p>
         </p:txBody>
@@ -9683,7 +9695,7 @@
                 </a:solidFill>
                 <a:latin typeface="Roboto"/>
               </a:rPr>
-              <a:t>The math</a:t>
+              <a:t>The cost</a:t>
             </a:r>
           </a:p>
         </p:txBody>
@@ -9725,7 +9737,7 @@
                 </a:solidFill>
                 <a:latin typeface="Roboto"/>
               </a:rPr>
-              <a:t>4 major versions of churn</a:t>
+              <a:t>Backlog grows, greenfield stalls</a:t>
             </a:r>
           </a:p>
           <a:p>
@@ -9744,7 +9756,7 @@
                 </a:solidFill>
                 <a:latin typeface="Roboto"/>
               </a:rPr>
-              <a:t>Months of senior-engineer time</a:t>
+              <a:t>Best engineers stuck on upkeep</a:t>
             </a:r>
           </a:p>
         </p:txBody>
@@ -9832,7 +9844,7 @@
                 </a:solidFill>
                 <a:latin typeface="Roboto"/>
               </a:rPr>
-              <a:t>The real constraint isn't code — it's coordinating 12 teams' calendars.</a:t>
+              <a:t>Every quarter spent on maintenance is a quarter not spent building.</a:t>
             </a:r>
           </a:p>
         </p:txBody>

</xml_diff>

<commit_message>
Update agenda speaker notes to reference dedicated why-BofA slide
Co-Authored-By: Devin AI <158243242+devin-ai-integration[bot]@users.noreply.github.com>
</commit_message>
<xml_diff>
--- a/presentation/BofA_x_Cognition_Devin_Demo.pptx
+++ b/presentation/BofA_x_Cognition_Devin_Demo.pptx
@@ -1023,7 +1023,7 @@
           <a:p/>
           <a:p>
             <a:r>
-              <a:t>--- "WHY I'M HERE (AND WHY BOFA)" — delivered verbally off this slide, ~2 min, no dedicated slide. Keep it brief; you represent Cognition, not your biography:</a:t>
+              <a:t>--- "WHY I'M HERE" — delivered verbally off this slide, ~2 min, no dedicated slide. Keep it brief; you represent Cognition, not your biography:</a:t>
             </a:r>
           </a:p>
           <a:p/>
@@ -1035,7 +1035,7 @@
           <a:p/>
           <a:p>
             <a:r>
-              <a:t>Then pivot to why BofA (one breath, then move on): "And BofA is exactly where this matters most — you're one of the biggest engineering orgs on the planet, ~$13B a year in tech, already AI-forward with Erica. At your scale, a systematic, fully-logged way to do this work isn't a nice-to-have."</a:t>
+              <a:t>Don't make the full why-BofA case here — that now has its own slide (slide 4, right after the problem slide, part of agenda item 2). Just tee it up in one breath: "And I'll say a word in a minute about why I think BofA specifically is the right place for this."</a:t>
             </a:r>
           </a:p>
           <a:p/>

</xml_diff>

<commit_message>
Add run-the-bank stat to problem slide; add adoption + social-proof to why-BofA slide
Co-Authored-By: Devin AI <158243242+devin-ai-integration[bot]@users.noreply.github.com>
</commit_message>
<xml_diff>
--- a/presentation/BofA_x_Cognition_Devin_Demo.pptx
+++ b/presentation/BofA_x_Cognition_Devin_Demo.pptx
@@ -1144,6 +1144,39 @@
           <a:p/>
           <a:p>
             <a:r>
+              <a:t>The "run the bank" number is your credibility anchor — deliver it slowly: "Consistent with industry benchmarks — McKinsey and Gartner both put it here — roughly 70% of a major bank's IT budget goes to 'run the bank' operational maintenance, leaving limited capacity for the work that actually differentiates you. Applied to your own public numbers — $13.5B in tech spend, $4B+ on new initiatives — that maintenance baseline is on the order of $9.5B a year. That is exactly the category of work Devin takes on."</a:t>
+            </a:r>
+          </a:p>
+          <a:p/>
+          <a:p>
+            <a:r>
+              <a:t>McKinsey quote if they want the source verbatim: "'run the bank' and 'mandatory change' spending often represents up to 70 percent of technology budgets... leaving only limited capacity for investments that can drive competitive differentiation."</a:t>
+            </a:r>
+          </a:p>
+          <a:p/>
+          <a:p>
+            <a:r>
+              <a:t>SOURCES (have these open in a tab):</a:t>
+            </a:r>
+          </a:p>
+          <a:p>
+            <a:r>
+              <a:t>- BofA Fast Facts — $13.5B tech, $4B+ new initiatives: https://newsroom.bankofamerica.com/content/newsroom/company-overview/bank-of-america-fast-facts.html</a:t>
+            </a:r>
+          </a:p>
+          <a:p>
+            <a:r>
+              <a:t>- McKinsey, "Unlocking value from technology in banking": https://www.mckinsey.com/industries/financial-services/our-insights/unlocking-value-from-technology-in-banking-an-investor-lens</a:t>
+            </a:r>
+          </a:p>
+          <a:p>
+            <a:r>
+              <a:t>Be clear the ~$9.5B is your own illustrative math (70% of $13.5B), not a figure BofA published — present it as "on the order of," not a hard number, in case someone checks.</a:t>
+            </a:r>
+          </a:p>
+          <a:p/>
+          <a:p>
+            <a:r>
               <a:t>Bridge to the demo (one line, don't dwell): "Today's concrete example is your Angular 14→18 migration — hard EOL deadline, millions of customers, a shared library with 12+ downstream teams. We'll dig into that live in the demo."</a:t>
             </a:r>
           </a:p>
@@ -1287,6 +1320,18 @@
           <a:p/>
           <a:p>
             <a:r>
+              <a:t>Adoption / "easy to pick up" point (land it on the VP Eng and Architect): "There's almost no new tool for your engineers to learn. Devin works through the same GitHub, the same pull requests, the same CI you already run. Your team's day-to-day changes from writing migrations by hand to reviewing PRs — something every engineer here already does all day. Onboarding is measured in hours, not a training program."</a:t>
+            </a:r>
+          </a:p>
+          <a:p/>
+          <a:p>
+            <a:r>
+              <a:t>Similar customers (social proof): "And you wouldn't be the first regulated enterprise to do this — [name the specific comparable customers/logos Cognition is cleared to reference here]." Only say names you are 100% authorized to share; if you can't name any, keep it general ("large regulated enterprises") rather than implying more than you can back up.</a:t>
+            </a:r>
+          </a:p>
+          <a:p/>
+          <a:p>
+            <a:r>
               <a:t>DERAIL-PREP: If someone says "scale cuts both ways — our estate is too messy for this": "That's exactly why we start with a bounded pilot on one slice, not a big-bang rollout. Messy is normal; we'll see how Devin handles it on your code."</a:t>
             </a:r>
           </a:p>
@@ -1304,6 +1349,11 @@
           <a:p>
             <a:r>
               <a:t>- Find 1–2 public BofA exec quotes on GenAI for developers to cite verbatim.</a:t>
+            </a:r>
+          </a:p>
+          <a:p>
+            <a:r>
+              <a:t>- Confirm which comparable enterprise/financial-services customers Cognition is cleared to name out loud, and have 1–2 ready.</a:t>
             </a:r>
           </a:p>
         </p:txBody>
@@ -11238,15 +11288,15 @@
         <p:spPr>
           <a:xfrm>
             <a:off x="502920" y="4526280"/>
-            <a:ext cx="11201400" cy="868680"/>
+            <a:ext cx="11201400" cy="1234440"/>
           </a:xfrm>
           <a:prstGeom prst="roundRect">
             <a:avLst>
-              <a:gd name="adj" fmla="val 10000"/>
+              <a:gd name="adj" fmla="val 9000"/>
             </a:avLst>
           </a:prstGeom>
           <a:solidFill>
-            <a:srgbClr val="F4F6F9"/>
+            <a:srgbClr val="012169"/>
           </a:solidFill>
           <a:ln>
             <a:noFill/>
@@ -11284,7 +11334,7 @@
         <p:spPr>
           <a:xfrm>
             <a:off x="777240" y="4736592"/>
-            <a:ext cx="10698480" cy="594360"/>
+            <a:ext cx="2468880" cy="868680"/>
           </a:xfrm>
           <a:prstGeom prst="rect">
             <a:avLst/>
@@ -11292,7 +11342,7 @@
           <a:noFill/>
         </p:spPr>
         <p:txBody>
-          <a:bodyPr wrap="square" anchor="t">
+          <a:bodyPr wrap="square" anchor="ctr">
             <a:spAutoFit/>
           </a:bodyPr>
           <a:lstStyle/>
@@ -11306,13 +11356,13 @@
               </a:spcAft>
             </a:pPr>
             <a:r>
-              <a:rPr sz="1600" b="1" i="0">
-                <a:solidFill>
-                  <a:srgbClr val="012169"/>
-                </a:solidFill>
-                <a:latin typeface="Roboto"/>
-              </a:rPr>
-              <a:t>Every quarter spent on maintenance is a quarter not spent building.</a:t>
+              <a:rPr sz="4200" b="1" i="0">
+                <a:solidFill>
+                  <a:srgbClr val="E31837"/>
+                </a:solidFill>
+                <a:latin typeface="Roboto"/>
+              </a:rPr>
+              <a:t>~70%</a:t>
             </a:r>
           </a:p>
         </p:txBody>
@@ -11320,6 +11370,67 @@
       <p:sp>
         <p:nvSpPr>
           <p:cNvPr id="22" name="TextBox 21"/>
+          <p:cNvSpPr txBox="1"/>
+          <p:nvPr/>
+        </p:nvSpPr>
+        <p:spPr>
+          <a:xfrm>
+            <a:off x="3200400" y="4736592"/>
+            <a:ext cx="8229600" cy="868680"/>
+          </a:xfrm>
+          <a:prstGeom prst="rect">
+            <a:avLst/>
+          </a:prstGeom>
+          <a:noFill/>
+        </p:spPr>
+        <p:txBody>
+          <a:bodyPr wrap="square" anchor="ctr">
+            <a:spAutoFit/>
+          </a:bodyPr>
+          <a:lstStyle/>
+          <a:p>
+            <a:pPr algn="l">
+              <a:lnSpc>
+                <a:spcPct val="100000"/>
+              </a:lnSpc>
+              <a:spcAft>
+                <a:spcPts val="600"/>
+              </a:spcAft>
+            </a:pPr>
+            <a:r>
+              <a:rPr sz="1500" b="1" i="0">
+                <a:solidFill>
+                  <a:srgbClr val="FFFFFF"/>
+                </a:solidFill>
+                <a:latin typeface="Roboto"/>
+              </a:rPr>
+              <a:t>of a major bank's tech budget goes to “running the bank,” not building it.</a:t>
+            </a:r>
+          </a:p>
+          <a:p>
+            <a:pPr algn="l">
+              <a:lnSpc>
+                <a:spcPct val="100000"/>
+              </a:lnSpc>
+              <a:spcAft>
+                <a:spcPts val="600"/>
+              </a:spcAft>
+            </a:pPr>
+            <a:r>
+              <a:rPr sz="1250" b="0" i="0">
+                <a:solidFill>
+                  <a:srgbClr val="C9D4EC"/>
+                </a:solidFill>
+                <a:latin typeface="Roboto"/>
+              </a:rPr>
+              <a:t>For BofA that's ~$9.5B of $13.5B — the exact work Devin absorbs.</a:t>
+            </a:r>
+          </a:p>
+        </p:txBody>
+      </p:sp>
+      <p:sp>
+        <p:nvSpPr>
+          <p:cNvPr id="23" name="TextBox 22"/>
           <p:cNvSpPr txBox="1"/>
           <p:nvPr/>
         </p:nvSpPr>
@@ -11760,7 +11871,7 @@
                 </a:solidFill>
                 <a:latin typeface="Roboto"/>
               </a:rPr>
-              <a:t>~$13B annual tech spend</a:t>
+              <a:t>~$13.5B annual tech spend</a:t>
             </a:r>
           </a:p>
           <a:p>
@@ -12104,7 +12215,7 @@
                 </a:solidFill>
                 <a:latin typeface="Roboto"/>
               </a:rPr>
-              <a:t>The environment</a:t>
+              <a:t>The fit</a:t>
             </a:r>
           </a:p>
         </p:txBody>
@@ -12165,7 +12276,7 @@
                 </a:solidFill>
                 <a:latin typeface="Roboto"/>
               </a:rPr>
-              <a:t>Devin's PR + log model fits it natively</a:t>
+              <a:t>Engineers keep their GitHub + PR flow</a:t>
             </a:r>
           </a:p>
         </p:txBody>
@@ -12253,7 +12364,7 @@
                 </a:solidFill>
                 <a:latin typeface="Roboto"/>
               </a:rPr>
-              <a:t>The bigger the estate, the bigger the payoff from doing this systematically.</a:t>
+              <a:t>Low switching cost — and already proven at large, regulated enterprises.</a:t>
             </a:r>
           </a:p>
         </p:txBody>

</xml_diff>

<commit_message>
Standardize tech budget figure to $13.5B across notes and appendix
Co-Authored-By: Devin AI <158243242+devin-ai-integration[bot]@users.noreply.github.com>
</commit_message>
<xml_diff>
--- a/presentation/BofA_x_Cognition_Devin_Demo.pptx
+++ b/presentation/BofA_x_Cognition_Devin_Demo.pptx
@@ -920,7 +920,7 @@
           </a:p>
           <a:p>
             <a:r>
-              <a:t>1. The ~$13B tech budget and Erica stats — these are your two 'I did my homework' credibility numbers; get them current and sourced.</a:t>
+              <a:t>1. The ~$13.5B tech budget and Erica stats — these are your two 'I did my homework' credibility numbers; get them current and sourced.</a:t>
             </a:r>
           </a:p>
           <a:p>
@@ -1052,7 +1052,7 @@
           </a:p>
           <a:p>
             <a:r>
-              <a:t>- Verify the current BofA tech budget figure (~$12–13B cited publicly; ~$3.5–4B on new initiatives) from their most recent earnings call.</a:t>
+              <a:t>- Verify the current BofA tech budget figure (~$13.5B total, $4B+ on new initiatives per BofA Fast Facts) from their most recent earnings call / newsroom.</a:t>
             </a:r>
           </a:p>
           <a:p>
@@ -1308,7 +1308,7 @@
           <a:p/>
           <a:p>
             <a:r>
-              <a:t>Talk track: "Three reasons this conversation makes more sense here than almost anywhere else. First, scale: at ~$13B a year in tech, even a small percentage of engineering capacity reclaimed from maintenance is enormous in absolute terms. Second, you're not AI-skeptics — Erica, the patent portfolio, your leadership's public statements — the organizational muscle to adopt this already exists. Third, and counterintuitively: your regulated environment is an advantage. Devin works through pull requests and leaves a complete session log — it was built for places where every change needs a paper trail."</a:t>
+              <a:t>Talk track: "Three reasons this conversation makes more sense here than almost anywhere else. First, scale: at ~$13.5B a year in tech, even a small percentage of engineering capacity reclaimed from maintenance is enormous in absolute terms. Second, you're not AI-skeptics — Erica, the patent portfolio, your leadership's public statements — the organizational muscle to adopt this already exists. Third, and counterintuitively: your regulated environment is an advantage. Devin works through pull requests and leaves a complete session log — it was built for places where every change needs a paper trail."</a:t>
             </a:r>
           </a:p>
           <a:p/>
@@ -8171,7 +8171,7 @@
                 </a:solidFill>
                 <a:latin typeface="Roboto"/>
               </a:rPr>
-              <a:t>BofA tech budget: verify latest figure (~$12–13B total, ~$3.5–4B new initiatives) from most recent earnings call.</a:t>
+              <a:t>BofA tech budget: verify latest figure (~$13.5B total, $4B+ new initiatives per BofA Fast Facts) from most recent earnings call / newsroom.</a:t>
             </a:r>
           </a:p>
           <a:p>

</xml_diff>

<commit_message>
Restyle security slide as horizontal editorial sections
Co-Authored-By: Devin AI <158243242+devin-ai-integration[bot]@users.noreply.github.com>
</commit_message>
<xml_diff>
--- a/presentation/BofA_x_Cognition_Devin_Demo.pptx
+++ b/presentation/BofA_x_Cognition_Devin_Demo.pptx
@@ -14734,60 +14734,14 @@
       </p:sp>
       <p:sp>
         <p:nvSpPr>
-          <p:cNvPr id="7" name="Rounded Rectangle 6"/>
+          <p:cNvPr id="7" name="Rectangle 6"/>
           <p:cNvSpPr/>
           <p:nvPr/>
         </p:nvSpPr>
         <p:spPr>
           <a:xfrm>
-            <a:off x="502920" y="1645920"/>
-            <a:ext cx="3611880" cy="2377440"/>
-          </a:xfrm>
-          <a:prstGeom prst="roundRect">
-            <a:avLst>
-              <a:gd name="adj" fmla="val 6000"/>
-            </a:avLst>
-          </a:prstGeom>
-          <a:solidFill>
-            <a:srgbClr val="F4F6F9"/>
-          </a:solidFill>
-          <a:ln>
-            <a:noFill/>
-          </a:ln>
-          <a:effectLst/>
-        </p:spPr>
-        <p:style>
-          <a:lnRef idx="1">
-            <a:schemeClr val="accent1"/>
-          </a:lnRef>
-          <a:fillRef idx="3">
-            <a:schemeClr val="accent1"/>
-          </a:fillRef>
-          <a:effectRef idx="2">
-            <a:schemeClr val="accent1"/>
-          </a:effectRef>
-          <a:fontRef idx="minor">
-            <a:schemeClr val="lt1"/>
-          </a:fontRef>
-        </p:style>
-        <p:txBody>
-          <a:bodyPr rtlCol="0" anchor="ctr"/>
-          <a:lstStyle/>
-          <a:p>
-            <a:pPr algn="ctr"/>
-          </a:p>
-        </p:txBody>
-      </p:sp>
-      <p:sp>
-        <p:nvSpPr>
-          <p:cNvPr id="8" name="Rectangle 7"/>
-          <p:cNvSpPr/>
-          <p:nvPr/>
-        </p:nvSpPr>
-        <p:spPr>
-          <a:xfrm>
-            <a:off x="502920" y="1755648"/>
-            <a:ext cx="54864" cy="2157984"/>
+            <a:off x="502920" y="1801368"/>
+            <a:ext cx="128016" cy="658368"/>
           </a:xfrm>
           <a:prstGeom prst="rect">
             <a:avLst/>
@@ -14824,14 +14778,56 @@
       </p:sp>
       <p:sp>
         <p:nvSpPr>
+          <p:cNvPr id="8" name="TextBox 7"/>
+          <p:cNvSpPr txBox="1"/>
+          <p:nvPr/>
+        </p:nvSpPr>
+        <p:spPr>
+          <a:xfrm>
+            <a:off x="868680" y="1691640"/>
+            <a:ext cx="3017520" cy="868680"/>
+          </a:xfrm>
+          <a:prstGeom prst="rect">
+            <a:avLst/>
+          </a:prstGeom>
+          <a:noFill/>
+        </p:spPr>
+        <p:txBody>
+          <a:bodyPr wrap="square" anchor="ctr">
+            <a:spAutoFit/>
+          </a:bodyPr>
+          <a:lstStyle/>
+          <a:p>
+            <a:pPr algn="l">
+              <a:lnSpc>
+                <a:spcPct val="100000"/>
+              </a:lnSpc>
+              <a:spcAft>
+                <a:spcPts val="600"/>
+              </a:spcAft>
+            </a:pPr>
+            <a:r>
+              <a:rPr sz="2600" b="1" i="0">
+                <a:solidFill>
+                  <a:srgbClr val="012169"/>
+                </a:solidFill>
+                <a:latin typeface="Roboto"/>
+              </a:rPr>
+              <a:t>Isolated</a:t>
+            </a:r>
+          </a:p>
+        </p:txBody>
+      </p:sp>
+      <p:sp>
+        <p:nvSpPr>
           <p:cNvPr id="9" name="TextBox 8"/>
           <p:cNvSpPr txBox="1"/>
           <p:nvPr/>
         </p:nvSpPr>
         <p:spPr>
           <a:xfrm>
-            <a:off x="704088" y="1755648"/>
-            <a:ext cx="3246120" cy="365760"/>
+            <a:off x="4069080" y="1691640"/>
+            <a:ext cx="7635240" cy="868680"/>
           </a:xfrm>
           <a:prstGeom prst="rect">
             <a:avLst/>
@@ -14839,7 +14835,7 @@
           <a:noFill/>
         </p:spPr>
         <p:txBody>
-          <a:bodyPr wrap="square" anchor="t">
+          <a:bodyPr wrap="square" anchor="ctr">
             <a:spAutoFit/>
           </a:bodyPr>
           <a:lstStyle/>
@@ -14853,96 +14849,33 @@
               </a:spcAft>
             </a:pPr>
             <a:r>
-              <a:rPr sz="1400" b="1" i="0">
-                <a:solidFill>
-                  <a:srgbClr val="012169"/>
-                </a:solidFill>
-                <a:latin typeface="Roboto"/>
-              </a:rPr>
-              <a:t>Isolated by design</a:t>
-            </a:r>
-          </a:p>
-        </p:txBody>
-      </p:sp>
-      <p:sp>
-        <p:nvSpPr>
-          <p:cNvPr id="10" name="TextBox 9"/>
-          <p:cNvSpPr txBox="1"/>
-          <p:nvPr/>
-        </p:nvSpPr>
-        <p:spPr>
-          <a:xfrm>
-            <a:off x="704088" y="2121408"/>
-            <a:ext cx="3246120" cy="1783080"/>
-          </a:xfrm>
-          <a:prstGeom prst="rect">
-            <a:avLst/>
-          </a:prstGeom>
-          <a:noFill/>
-        </p:spPr>
-        <p:txBody>
-          <a:bodyPr wrap="square" anchor="t">
-            <a:spAutoFit/>
-          </a:bodyPr>
-          <a:lstStyle/>
-          <a:p>
-            <a:pPr algn="l">
-              <a:lnSpc>
-                <a:spcPct val="105000"/>
-              </a:lnSpc>
-              <a:spcAft>
-                <a:spcPts val="500"/>
-              </a:spcAft>
-            </a:pPr>
-            <a:r>
-              <a:rPr sz="1400" b="0" i="0">
+              <a:rPr sz="1500" b="0" i="0">
                 <a:solidFill>
                   <a:srgbClr val="1C2430"/>
                 </a:solidFill>
                 <a:latin typeface="Roboto"/>
               </a:rPr>
-              <a:t>One isolated machine per session</a:t>
-            </a:r>
-          </a:p>
-          <a:p>
-            <a:pPr algn="l">
-              <a:lnSpc>
-                <a:spcPct val="105000"/>
-              </a:lnSpc>
-              <a:spcAft>
-                <a:spcPts val="500"/>
-              </a:spcAft>
-            </a:pPr>
-            <a:r>
-              <a:rPr sz="1400" b="0" i="0">
-                <a:solidFill>
-                  <a:srgbClr val="1C2430"/>
-                </a:solidFill>
-                <a:latin typeface="Roboto"/>
-              </a:rPr>
-              <a:t>Encrypted in transit &amp; at rest</a:t>
-            </a:r>
-          </a:p>
-        </p:txBody>
-      </p:sp>
-      <p:sp>
-        <p:nvSpPr>
-          <p:cNvPr id="11" name="Rounded Rectangle 10"/>
+              <a:t>One isolated machine per session — encrypted in transit &amp; at rest.</a:t>
+            </a:r>
+          </a:p>
+        </p:txBody>
+      </p:sp>
+      <p:sp>
+        <p:nvSpPr>
+          <p:cNvPr id="10" name="Rectangle 9"/>
           <p:cNvSpPr/>
           <p:nvPr/>
         </p:nvSpPr>
         <p:spPr>
           <a:xfrm>
-            <a:off x="4297680" y="1645920"/>
-            <a:ext cx="3611880" cy="2377440"/>
-          </a:xfrm>
-          <a:prstGeom prst="roundRect">
-            <a:avLst>
-              <a:gd name="adj" fmla="val 6000"/>
-            </a:avLst>
+            <a:off x="502920" y="2569464"/>
+            <a:ext cx="11201400" cy="14630"/>
+          </a:xfrm>
+          <a:prstGeom prst="rect">
+            <a:avLst/>
           </a:prstGeom>
           <a:solidFill>
-            <a:srgbClr val="F4F6F9"/>
+            <a:srgbClr val="D5DCE8"/>
           </a:solidFill>
           <a:ln>
             <a:noFill/>
@@ -14973,14 +14906,14 @@
       </p:sp>
       <p:sp>
         <p:nvSpPr>
-          <p:cNvPr id="12" name="Rectangle 11"/>
+          <p:cNvPr id="11" name="Rectangle 10"/>
           <p:cNvSpPr/>
           <p:nvPr/>
         </p:nvSpPr>
         <p:spPr>
           <a:xfrm>
-            <a:off x="4297680" y="1755648"/>
-            <a:ext cx="54864" cy="2157984"/>
+            <a:off x="502920" y="2953512"/>
+            <a:ext cx="128016" cy="658368"/>
           </a:xfrm>
           <a:prstGeom prst="rect">
             <a:avLst/>
@@ -15017,14 +14950,56 @@
       </p:sp>
       <p:sp>
         <p:nvSpPr>
+          <p:cNvPr id="12" name="TextBox 11"/>
+          <p:cNvSpPr txBox="1"/>
+          <p:nvPr/>
+        </p:nvSpPr>
+        <p:spPr>
+          <a:xfrm>
+            <a:off x="868680" y="2843784"/>
+            <a:ext cx="3017520" cy="868680"/>
+          </a:xfrm>
+          <a:prstGeom prst="rect">
+            <a:avLst/>
+          </a:prstGeom>
+          <a:noFill/>
+        </p:spPr>
+        <p:txBody>
+          <a:bodyPr wrap="square" anchor="ctr">
+            <a:spAutoFit/>
+          </a:bodyPr>
+          <a:lstStyle/>
+          <a:p>
+            <a:pPr algn="l">
+              <a:lnSpc>
+                <a:spcPct val="100000"/>
+              </a:lnSpc>
+              <a:spcAft>
+                <a:spcPts val="600"/>
+              </a:spcAft>
+            </a:pPr>
+            <a:r>
+              <a:rPr sz="2600" b="1" i="0">
+                <a:solidFill>
+                  <a:srgbClr val="012169"/>
+                </a:solidFill>
+                <a:latin typeface="Roboto"/>
+              </a:rPr>
+              <a:t>Private</a:t>
+            </a:r>
+          </a:p>
+        </p:txBody>
+      </p:sp>
+      <p:sp>
+        <p:nvSpPr>
           <p:cNvPr id="13" name="TextBox 12"/>
           <p:cNvSpPr txBox="1"/>
           <p:nvPr/>
         </p:nvSpPr>
         <p:spPr>
           <a:xfrm>
-            <a:off x="4498848" y="1755648"/>
-            <a:ext cx="3246120" cy="365760"/>
+            <a:off x="4069080" y="2843784"/>
+            <a:ext cx="7635240" cy="868680"/>
           </a:xfrm>
           <a:prstGeom prst="rect">
             <a:avLst/>
@@ -15032,7 +15007,7 @@
           <a:noFill/>
         </p:spPr>
         <p:txBody>
-          <a:bodyPr wrap="square" anchor="t">
+          <a:bodyPr wrap="square" anchor="ctr">
             <a:spAutoFit/>
           </a:bodyPr>
           <a:lstStyle/>
@@ -15046,96 +15021,33 @@
               </a:spcAft>
             </a:pPr>
             <a:r>
-              <a:rPr sz="1400" b="1" i="0">
-                <a:solidFill>
-                  <a:srgbClr val="012169"/>
-                </a:solidFill>
-                <a:latin typeface="Roboto"/>
-              </a:rPr>
-              <a:t>Deploys your way</a:t>
-            </a:r>
-          </a:p>
-        </p:txBody>
-      </p:sp>
-      <p:sp>
-        <p:nvSpPr>
-          <p:cNvPr id="14" name="TextBox 13"/>
-          <p:cNvSpPr txBox="1"/>
-          <p:nvPr/>
-        </p:nvSpPr>
-        <p:spPr>
-          <a:xfrm>
-            <a:off x="4498848" y="2121408"/>
-            <a:ext cx="3246120" cy="1783080"/>
-          </a:xfrm>
-          <a:prstGeom prst="rect">
-            <a:avLst/>
-          </a:prstGeom>
-          <a:noFill/>
-        </p:spPr>
-        <p:txBody>
-          <a:bodyPr wrap="square" anchor="t">
-            <a:spAutoFit/>
-          </a:bodyPr>
-          <a:lstStyle/>
-          <a:p>
-            <a:pPr algn="l">
-              <a:lnSpc>
-                <a:spcPct val="105000"/>
-              </a:lnSpc>
-              <a:spcAft>
-                <a:spcPts val="500"/>
-              </a:spcAft>
-            </a:pPr>
-            <a:r>
-              <a:rPr sz="1400" b="0" i="0">
+              <a:rPr sz="1500" b="0" i="0">
                 <a:solidFill>
                   <a:srgbClr val="1C2430"/>
                 </a:solidFill>
                 <a:latin typeface="Roboto"/>
               </a:rPr>
-              <a:t>Enterprise Cloud, or</a:t>
-            </a:r>
-          </a:p>
-          <a:p>
-            <a:pPr algn="l">
-              <a:lnSpc>
-                <a:spcPct val="105000"/>
-              </a:lnSpc>
-              <a:spcAft>
-                <a:spcPts val="500"/>
-              </a:spcAft>
-            </a:pPr>
-            <a:r>
-              <a:rPr sz="1400" b="0" i="0">
-                <a:solidFill>
-                  <a:srgbClr val="1C2430"/>
-                </a:solidFill>
-                <a:latin typeface="Roboto"/>
-              </a:rPr>
-              <a:t>Single-tenant VPC via AWS PrivateLink</a:t>
-            </a:r>
-          </a:p>
-        </p:txBody>
-      </p:sp>
-      <p:sp>
-        <p:nvSpPr>
-          <p:cNvPr id="15" name="Rounded Rectangle 14"/>
+              <a:t>Enterprise Cloud, or a single-tenant VPC connected via AWS PrivateLink.</a:t>
+            </a:r>
+          </a:p>
+        </p:txBody>
+      </p:sp>
+      <p:sp>
+        <p:nvSpPr>
+          <p:cNvPr id="14" name="Rectangle 13"/>
           <p:cNvSpPr/>
           <p:nvPr/>
         </p:nvSpPr>
         <p:spPr>
           <a:xfrm>
-            <a:off x="8092440" y="1645920"/>
-            <a:ext cx="3611880" cy="2377440"/>
-          </a:xfrm>
-          <a:prstGeom prst="roundRect">
-            <a:avLst>
-              <a:gd name="adj" fmla="val 6000"/>
-            </a:avLst>
+            <a:off x="502920" y="3721608"/>
+            <a:ext cx="11201400" cy="14630"/>
+          </a:xfrm>
+          <a:prstGeom prst="rect">
+            <a:avLst/>
           </a:prstGeom>
           <a:solidFill>
-            <a:srgbClr val="F4F6F9"/>
+            <a:srgbClr val="D5DCE8"/>
           </a:solidFill>
           <a:ln>
             <a:noFill/>
@@ -15166,14 +15078,14 @@
       </p:sp>
       <p:sp>
         <p:nvSpPr>
-          <p:cNvPr id="16" name="Rectangle 15"/>
+          <p:cNvPr id="15" name="Rectangle 14"/>
           <p:cNvSpPr/>
           <p:nvPr/>
         </p:nvSpPr>
         <p:spPr>
           <a:xfrm>
-            <a:off x="8092440" y="1755648"/>
-            <a:ext cx="54864" cy="2157984"/>
+            <a:off x="502920" y="4105656"/>
+            <a:ext cx="128016" cy="658368"/>
           </a:xfrm>
           <a:prstGeom prst="rect">
             <a:avLst/>
@@ -15210,14 +15122,56 @@
       </p:sp>
       <p:sp>
         <p:nvSpPr>
+          <p:cNvPr id="16" name="TextBox 15"/>
+          <p:cNvSpPr txBox="1"/>
+          <p:nvPr/>
+        </p:nvSpPr>
+        <p:spPr>
+          <a:xfrm>
+            <a:off x="868680" y="3995928"/>
+            <a:ext cx="3017520" cy="868680"/>
+          </a:xfrm>
+          <a:prstGeom prst="rect">
+            <a:avLst/>
+          </a:prstGeom>
+          <a:noFill/>
+        </p:spPr>
+        <p:txBody>
+          <a:bodyPr wrap="square" anchor="ctr">
+            <a:spAutoFit/>
+          </a:bodyPr>
+          <a:lstStyle/>
+          <a:p>
+            <a:pPr algn="l">
+              <a:lnSpc>
+                <a:spcPct val="100000"/>
+              </a:lnSpc>
+              <a:spcAft>
+                <a:spcPts val="600"/>
+              </a:spcAft>
+            </a:pPr>
+            <a:r>
+              <a:rPr sz="2600" b="1" i="0">
+                <a:solidFill>
+                  <a:srgbClr val="012169"/>
+                </a:solidFill>
+                <a:latin typeface="Roboto"/>
+              </a:rPr>
+              <a:t>Controlled</a:t>
+            </a:r>
+          </a:p>
+        </p:txBody>
+      </p:sp>
+      <p:sp>
+        <p:nvSpPr>
           <p:cNvPr id="17" name="TextBox 16"/>
           <p:cNvSpPr txBox="1"/>
           <p:nvPr/>
         </p:nvSpPr>
         <p:spPr>
           <a:xfrm>
-            <a:off x="8293608" y="1755648"/>
-            <a:ext cx="3246120" cy="365760"/>
+            <a:off x="4069080" y="3995928"/>
+            <a:ext cx="7635240" cy="868680"/>
           </a:xfrm>
           <a:prstGeom prst="rect">
             <a:avLst/>
@@ -15225,7 +15179,7 @@
           <a:noFill/>
         </p:spPr>
         <p:txBody>
-          <a:bodyPr wrap="square" anchor="t">
+          <a:bodyPr wrap="square" anchor="ctr">
             <a:spAutoFit/>
           </a:bodyPr>
           <a:lstStyle/>
@@ -15239,93 +15193,30 @@
               </a:spcAft>
             </a:pPr>
             <a:r>
-              <a:rPr sz="1400" b="1" i="0">
-                <a:solidFill>
-                  <a:srgbClr val="012169"/>
-                </a:solidFill>
-                <a:latin typeface="Roboto"/>
-              </a:rPr>
-              <a:t>Your controls</a:t>
-            </a:r>
-          </a:p>
-        </p:txBody>
-      </p:sp>
-      <p:sp>
-        <p:nvSpPr>
-          <p:cNvPr id="18" name="TextBox 17"/>
-          <p:cNvSpPr txBox="1"/>
-          <p:nvPr/>
-        </p:nvSpPr>
-        <p:spPr>
-          <a:xfrm>
-            <a:off x="8293608" y="2121408"/>
-            <a:ext cx="3246120" cy="1783080"/>
-          </a:xfrm>
-          <a:prstGeom prst="rect">
-            <a:avLst/>
-          </a:prstGeom>
-          <a:noFill/>
-        </p:spPr>
-        <p:txBody>
-          <a:bodyPr wrap="square" anchor="t">
-            <a:spAutoFit/>
-          </a:bodyPr>
-          <a:lstStyle/>
-          <a:p>
-            <a:pPr algn="l">
-              <a:lnSpc>
-                <a:spcPct val="105000"/>
-              </a:lnSpc>
-              <a:spcAft>
-                <a:spcPts val="500"/>
-              </a:spcAft>
-            </a:pPr>
-            <a:r>
-              <a:rPr sz="1400" b="0" i="0">
+              <a:rPr sz="1500" b="0" i="0">
                 <a:solidFill>
                   <a:srgbClr val="1C2430"/>
                 </a:solidFill>
                 <a:latin typeface="Roboto"/>
               </a:rPr>
-              <a:t>SSO · Okta / Entra / SAML</a:t>
-            </a:r>
-          </a:p>
-          <a:p>
-            <a:pPr algn="l">
-              <a:lnSpc>
-                <a:spcPct val="105000"/>
-              </a:lnSpc>
-              <a:spcAft>
-                <a:spcPts val="500"/>
-              </a:spcAft>
-            </a:pPr>
-            <a:r>
-              <a:rPr sz="1400" b="0" i="0">
-                <a:solidFill>
-                  <a:srgbClr val="1C2430"/>
-                </a:solidFill>
-                <a:latin typeface="Roboto"/>
-              </a:rPr>
-              <a:t>Nothing merges without your review</a:t>
-            </a:r>
-          </a:p>
-        </p:txBody>
-      </p:sp>
-      <p:sp>
-        <p:nvSpPr>
-          <p:cNvPr id="19" name="Rounded Rectangle 18"/>
+              <a:t>SSO (Okta / Entra / SAML) — and nothing merges without your review.</a:t>
+            </a:r>
+          </a:p>
+        </p:txBody>
+      </p:sp>
+      <p:sp>
+        <p:nvSpPr>
+          <p:cNvPr id="18" name="Rectangle 17"/>
           <p:cNvSpPr/>
           <p:nvPr/>
         </p:nvSpPr>
         <p:spPr>
           <a:xfrm>
-            <a:off x="502920" y="4343400"/>
-            <a:ext cx="11201400" cy="868680"/>
-          </a:xfrm>
-          <a:prstGeom prst="roundRect">
-            <a:avLst>
-              <a:gd name="adj" fmla="val 10000"/>
-            </a:avLst>
+            <a:off x="0" y="5349240"/>
+            <a:ext cx="12191695" cy="914400"/>
+          </a:xfrm>
+          <a:prstGeom prst="rect">
+            <a:avLst/>
           </a:prstGeom>
           <a:solidFill>
             <a:srgbClr val="012169"/>
@@ -15359,13 +15250,13 @@
       </p:sp>
       <p:sp>
         <p:nvSpPr>
-          <p:cNvPr id="20" name="TextBox 19"/>
+          <p:cNvPr id="19" name="TextBox 18"/>
           <p:cNvSpPr txBox="1"/>
           <p:nvPr/>
         </p:nvSpPr>
         <p:spPr>
           <a:xfrm>
-            <a:off x="777240" y="4553712"/>
+            <a:off x="868680" y="5513832"/>
             <a:ext cx="10698480" cy="594360"/>
           </a:xfrm>
           <a:prstGeom prst="rect">
@@ -15374,7 +15265,7 @@
           <a:noFill/>
         </p:spPr>
         <p:txBody>
-          <a:bodyPr wrap="square" anchor="t">
+          <a:bodyPr wrap="square" anchor="ctr">
             <a:spAutoFit/>
           </a:bodyPr>
           <a:lstStyle/>
@@ -15395,48 +15286,6 @@
                 <a:latin typeface="Roboto"/>
               </a:rPr>
               <a:t>Every command, file change, and test run — logged and replayable.</a:t>
-            </a:r>
-          </a:p>
-        </p:txBody>
-      </p:sp>
-      <p:sp>
-        <p:nvSpPr>
-          <p:cNvPr id="21" name="TextBox 20"/>
-          <p:cNvSpPr txBox="1"/>
-          <p:nvPr/>
-        </p:nvSpPr>
-        <p:spPr>
-          <a:xfrm>
-            <a:off x="502920" y="6473952"/>
-            <a:ext cx="7315200" cy="292608"/>
-          </a:xfrm>
-          <a:prstGeom prst="rect">
-            <a:avLst/>
-          </a:prstGeom>
-          <a:noFill/>
-        </p:spPr>
-        <p:txBody>
-          <a:bodyPr wrap="square" anchor="t">
-            <a:spAutoFit/>
-          </a:bodyPr>
-          <a:lstStyle/>
-          <a:p>
-            <a:pPr algn="l">
-              <a:lnSpc>
-                <a:spcPct val="100000"/>
-              </a:lnSpc>
-              <a:spcAft>
-                <a:spcPts val="600"/>
-              </a:spcAft>
-            </a:pPr>
-            <a:r>
-              <a:rPr sz="900" b="0" i="0">
-                <a:solidFill>
-                  <a:srgbClr val="5A6472"/>
-                </a:solidFill>
-                <a:latin typeface="Roboto"/>
-              </a:rPr>
-              <a:t>Bank of America  ×  Cognition</a:t>
             </a:r>
           </a:p>
         </p:txBody>

</xml_diff>

<commit_message>
Make next steps Angular-specific; larger centered rows, drop bottom ask line
Co-Authored-By: Devin AI <158243242+devin-ai-integration[bot]@users.noreply.github.com>
</commit_message>
<xml_diff>
--- a/presentation/BofA_x_Cognition_Devin_Demo.pptx
+++ b/presentation/BofA_x_Cognition_Devin_Demo.pptx
@@ -722,19 +722,19 @@
           <a:p/>
           <a:p>
             <a:r>
-              <a:t>Talk track: "Here's what I'd propose. First, we sit down together and pick three use cases — the natural starting points are work like what you just watched: framework upgrades, migrations, test-coverage debt — but you know your backlog; whatever you'd never staff greenfield engineers on is a candidate. Then a security and data review so your team is comfortable. Then we run a pilot on ONE of the three — a real repo, four weeks, measured against criteria you define. If it earns its keep, we scale to the other two. If it doesn't, you've spent almost nothing finding out."</a:t>
+              <a:t>Talk track: "You just watched the proof of concept — now let's do it for real. Step one, we scope your actual Angular estate together: which repos are on 14, where the shared library sits, who consumes it downstream. Step two, a security and data review so your team is comfortable, and we agree the success criteria up front. Then weeks two to four: Devin migrates your real shared library, 14 to 18, and your engineers review every PR — same thing you saw today, on your code. Week four, we're back in this room with results, and if it earned its keep, we point Devin at the downstream apps in parallel. If it didn't, you've spent four weeks finding out."</a:t>
             </a:r>
           </a:p>
           <a:p/>
           <a:p>
             <a:r>
-              <a:t>Why 3 use cases but 1 pilot: picking three gets them mentally invested in a roadmap (not a one-off experiment), while piloting one keeps the ask small enough to say yes to today.</a:t>
+              <a:t>Why the shared library as the pilot slice: it's the root of the dependency tree — proving it there de-risks everything downstream, and it's the exact shape of what they saw in the demo. If they'd rather start on a lower-stakes repo, flex immediately; the structure holds.</a:t>
             </a:r>
           </a:p>
           <a:p/>
           <a:p>
             <a:r>
-              <a:t>Assign ownership live: use-case shortlist → VP Eng (it's their backlog); security review → Security Engineer; pilot repo + success criteria → Chief Architect. People who own a step show up to the next meeting.</a:t>
+              <a:t>Assign ownership live: estate scoping → Chief Architect (they know the dependency tree); security review → Security Engineer; sponsorship + success criteria → VP Eng. People who own a step show up to the next meeting.</a:t>
             </a:r>
           </a:p>
           <a:p/>
@@ -6487,8 +6487,8 @@
         </p:nvSpPr>
         <p:spPr>
           <a:xfrm>
-            <a:off x="502920" y="1481328"/>
-            <a:ext cx="11201400" cy="932688"/>
+            <a:off x="502920" y="1444752"/>
+            <a:ext cx="11201400" cy="1115568"/>
           </a:xfrm>
           <a:prstGeom prst="roundRect">
             <a:avLst>
@@ -6533,8 +6533,8 @@
         </p:nvSpPr>
         <p:spPr>
           <a:xfrm>
-            <a:off x="658368" y="1682496"/>
-            <a:ext cx="530352" cy="530352"/>
+            <a:off x="713232" y="1719072"/>
+            <a:ext cx="566928" cy="566928"/>
           </a:xfrm>
           <a:prstGeom prst="ellipse">
             <a:avLst/>
@@ -6577,8 +6577,8 @@
         </p:nvSpPr>
         <p:spPr>
           <a:xfrm>
-            <a:off x="658368" y="1755648"/>
-            <a:ext cx="530352" cy="402336"/>
+            <a:off x="713232" y="1783080"/>
+            <a:ext cx="566928" cy="438912"/>
           </a:xfrm>
           <a:prstGeom prst="rect">
             <a:avLst/>
@@ -6600,7 +6600,7 @@
               </a:spcAft>
             </a:pPr>
             <a:r>
-              <a:rPr sz="1700" b="1" i="0">
+              <a:rPr sz="1800" b="1" i="0">
                 <a:solidFill>
                   <a:srgbClr val="FFFFFF"/>
                 </a:solidFill>
@@ -6619,8 +6619,8 @@
         </p:nvSpPr>
         <p:spPr>
           <a:xfrm>
-            <a:off x="1417320" y="1591056"/>
-            <a:ext cx="1417320" cy="685800"/>
+            <a:off x="1508760" y="1444752"/>
+            <a:ext cx="1417320" cy="1115568"/>
           </a:xfrm>
           <a:prstGeom prst="rect">
             <a:avLst/>
@@ -6628,7 +6628,7 @@
           <a:noFill/>
         </p:spPr>
         <p:txBody>
-          <a:bodyPr wrap="square" anchor="t">
+          <a:bodyPr wrap="square" anchor="ctr">
             <a:spAutoFit/>
           </a:bodyPr>
           <a:lstStyle/>
@@ -6642,7 +6642,7 @@
               </a:spcAft>
             </a:pPr>
             <a:r>
-              <a:rPr sz="1150" b="1" i="0">
+              <a:rPr sz="1200" b="1" i="0">
                 <a:solidFill>
                   <a:srgbClr val="E31837"/>
                 </a:solidFill>
@@ -6661,8 +6661,8 @@
         </p:nvSpPr>
         <p:spPr>
           <a:xfrm>
-            <a:off x="2834640" y="1591056"/>
-            <a:ext cx="8595360" cy="365760"/>
+            <a:off x="3017520" y="1444752"/>
+            <a:ext cx="8503920" cy="1115568"/>
           </a:xfrm>
           <a:prstGeom prst="rect">
             <a:avLst/>
@@ -6670,7 +6670,7 @@
           <a:noFill/>
         </p:spPr>
         <p:txBody>
-          <a:bodyPr wrap="square" anchor="t">
+          <a:bodyPr wrap="square" anchor="ctr">
             <a:spAutoFit/>
           </a:bodyPr>
           <a:lstStyle/>
@@ -6684,38 +6684,15 @@
               </a:spcAft>
             </a:pPr>
             <a:r>
-              <a:rPr sz="1450" b="1" i="0">
+              <a:rPr sz="1600" b="1" i="0">
                 <a:solidFill>
                   <a:srgbClr val="012169"/>
                 </a:solidFill>
                 <a:latin typeface="Roboto"/>
               </a:rPr>
-              <a:t>Pick 3 use cases together</a:t>
-            </a:r>
-          </a:p>
-        </p:txBody>
-      </p:sp>
-      <p:sp>
-        <p:nvSpPr>
-          <p:cNvPr id="12" name="TextBox 11"/>
-          <p:cNvSpPr txBox="1"/>
-          <p:nvPr/>
-        </p:nvSpPr>
-        <p:spPr>
-          <a:xfrm>
-            <a:off x="2834640" y="1938528"/>
-            <a:ext cx="8595360" cy="411480"/>
-          </a:xfrm>
-          <a:prstGeom prst="rect">
-            <a:avLst/>
-          </a:prstGeom>
-          <a:noFill/>
-        </p:spPr>
-        <p:txBody>
-          <a:bodyPr wrap="square" anchor="t">
-            <a:spAutoFit/>
-          </a:bodyPr>
-          <a:lstStyle/>
+              <a:t>Scope your Angular estate</a:t>
+            </a:r>
+          </a:p>
           <a:p>
             <a:pPr algn="l">
               <a:lnSpc>
@@ -6726,27 +6703,27 @@
               </a:spcAft>
             </a:pPr>
             <a:r>
-              <a:rPr sz="1150" b="0" i="0">
+              <a:rPr sz="1200" b="0" i="0">
                 <a:solidFill>
                   <a:srgbClr val="1C2430"/>
                 </a:solidFill>
                 <a:latin typeface="Roboto"/>
               </a:rPr>
-              <a:t>Start with work like today's demo — upgrades, migrations, test debt</a:t>
-            </a:r>
-          </a:p>
-        </p:txBody>
-      </p:sp>
-      <p:sp>
-        <p:nvSpPr>
-          <p:cNvPr id="13" name="Rounded Rectangle 12"/>
+              <a:t>Inventory the 14.x repos — shared library, downstream consumers, test coverage</a:t>
+            </a:r>
+          </a:p>
+        </p:txBody>
+      </p:sp>
+      <p:sp>
+        <p:nvSpPr>
+          <p:cNvPr id="12" name="Rounded Rectangle 11"/>
           <p:cNvSpPr/>
           <p:nvPr/>
         </p:nvSpPr>
         <p:spPr>
           <a:xfrm>
-            <a:off x="502920" y="2505456"/>
-            <a:ext cx="11201400" cy="932688"/>
+            <a:off x="502920" y="2688336"/>
+            <a:ext cx="11201400" cy="1115568"/>
           </a:xfrm>
           <a:prstGeom prst="roundRect">
             <a:avLst>
@@ -6785,14 +6762,14 @@
       </p:sp>
       <p:sp>
         <p:nvSpPr>
-          <p:cNvPr id="14" name="Oval 13"/>
+          <p:cNvPr id="13" name="Oval 12"/>
           <p:cNvSpPr/>
           <p:nvPr/>
         </p:nvSpPr>
         <p:spPr>
           <a:xfrm>
-            <a:off x="658368" y="2706624"/>
-            <a:ext cx="530352" cy="530352"/>
+            <a:off x="713232" y="2962656"/>
+            <a:ext cx="566928" cy="566928"/>
           </a:xfrm>
           <a:prstGeom prst="ellipse">
             <a:avLst/>
@@ -6829,14 +6806,14 @@
       </p:sp>
       <p:sp>
         <p:nvSpPr>
-          <p:cNvPr id="15" name="TextBox 14"/>
+          <p:cNvPr id="14" name="TextBox 13"/>
           <p:cNvSpPr txBox="1"/>
           <p:nvPr/>
         </p:nvSpPr>
         <p:spPr>
           <a:xfrm>
-            <a:off x="658368" y="2779776"/>
-            <a:ext cx="530352" cy="402336"/>
+            <a:off x="713232" y="3026663"/>
+            <a:ext cx="566928" cy="438912"/>
           </a:xfrm>
           <a:prstGeom prst="rect">
             <a:avLst/>
@@ -6858,13 +6835,55 @@
               </a:spcAft>
             </a:pPr>
             <a:r>
-              <a:rPr sz="1700" b="1" i="0">
+              <a:rPr sz="1800" b="1" i="0">
                 <a:solidFill>
                   <a:srgbClr val="FFFFFF"/>
                 </a:solidFill>
                 <a:latin typeface="Roboto"/>
               </a:rPr>
               <a:t>2</a:t>
+            </a:r>
+          </a:p>
+        </p:txBody>
+      </p:sp>
+      <p:sp>
+        <p:nvSpPr>
+          <p:cNvPr id="15" name="TextBox 14"/>
+          <p:cNvSpPr txBox="1"/>
+          <p:nvPr/>
+        </p:nvSpPr>
+        <p:spPr>
+          <a:xfrm>
+            <a:off x="1508760" y="2688336"/>
+            <a:ext cx="1417320" cy="1115568"/>
+          </a:xfrm>
+          <a:prstGeom prst="rect">
+            <a:avLst/>
+          </a:prstGeom>
+          <a:noFill/>
+        </p:spPr>
+        <p:txBody>
+          <a:bodyPr wrap="square" anchor="ctr">
+            <a:spAutoFit/>
+          </a:bodyPr>
+          <a:lstStyle/>
+          <a:p>
+            <a:pPr algn="l">
+              <a:lnSpc>
+                <a:spcPct val="100000"/>
+              </a:lnSpc>
+              <a:spcAft>
+                <a:spcPts val="600"/>
+              </a:spcAft>
+            </a:pPr>
+            <a:r>
+              <a:rPr sz="1200" b="1" i="0">
+                <a:solidFill>
+                  <a:srgbClr val="E31837"/>
+                </a:solidFill>
+                <a:latin typeface="Roboto"/>
+              </a:rPr>
+              <a:t>Next week</a:t>
             </a:r>
           </a:p>
         </p:txBody>
@@ -6877,8 +6896,8 @@
         </p:nvSpPr>
         <p:spPr>
           <a:xfrm>
-            <a:off x="1417320" y="2615184"/>
-            <a:ext cx="1417320" cy="685800"/>
+            <a:off x="3017520" y="2688336"/>
+            <a:ext cx="8503920" cy="1115568"/>
           </a:xfrm>
           <a:prstGeom prst="rect">
             <a:avLst/>
@@ -6886,7 +6905,7 @@
           <a:noFill/>
         </p:spPr>
         <p:txBody>
-          <a:bodyPr wrap="square" anchor="t">
+          <a:bodyPr wrap="square" anchor="ctr">
             <a:spAutoFit/>
           </a:bodyPr>
           <a:lstStyle/>
@@ -6900,38 +6919,15 @@
               </a:spcAft>
             </a:pPr>
             <a:r>
-              <a:rPr sz="1150" b="1" i="0">
-                <a:solidFill>
-                  <a:srgbClr val="E31837"/>
-                </a:solidFill>
-                <a:latin typeface="Roboto"/>
-              </a:rPr>
-              <a:t>Next week</a:t>
-            </a:r>
-          </a:p>
-        </p:txBody>
-      </p:sp>
-      <p:sp>
-        <p:nvSpPr>
-          <p:cNvPr id="17" name="TextBox 16"/>
-          <p:cNvSpPr txBox="1"/>
-          <p:nvPr/>
-        </p:nvSpPr>
-        <p:spPr>
-          <a:xfrm>
-            <a:off x="2834640" y="2615184"/>
-            <a:ext cx="8595360" cy="365760"/>
-          </a:xfrm>
-          <a:prstGeom prst="rect">
-            <a:avLst/>
-          </a:prstGeom>
-          <a:noFill/>
-        </p:spPr>
-        <p:txBody>
-          <a:bodyPr wrap="square" anchor="t">
-            <a:spAutoFit/>
-          </a:bodyPr>
-          <a:lstStyle/>
+              <a:rPr sz="1600" b="1" i="0">
+                <a:solidFill>
+                  <a:srgbClr val="012169"/>
+                </a:solidFill>
+                <a:latin typeface="Roboto"/>
+              </a:rPr>
+              <a:t>Security &amp; data review</a:t>
+            </a:r>
+          </a:p>
           <a:p>
             <a:pPr algn="l">
               <a:lnSpc>
@@ -6942,69 +6938,27 @@
               </a:spcAft>
             </a:pPr>
             <a:r>
-              <a:rPr sz="1450" b="1" i="0">
-                <a:solidFill>
-                  <a:srgbClr val="012169"/>
-                </a:solidFill>
-                <a:latin typeface="Roboto"/>
-              </a:rPr>
-              <a:t>Security &amp; data review</a:t>
-            </a:r>
-          </a:p>
-        </p:txBody>
-      </p:sp>
-      <p:sp>
-        <p:nvSpPr>
-          <p:cNvPr id="18" name="TextBox 17"/>
-          <p:cNvSpPr txBox="1"/>
-          <p:nvPr/>
-        </p:nvSpPr>
-        <p:spPr>
-          <a:xfrm>
-            <a:off x="2834640" y="2962656"/>
-            <a:ext cx="8595360" cy="411480"/>
-          </a:xfrm>
-          <a:prstGeom prst="rect">
-            <a:avLst/>
-          </a:prstGeom>
-          <a:noFill/>
-        </p:spPr>
-        <p:txBody>
-          <a:bodyPr wrap="square" anchor="t">
-            <a:spAutoFit/>
-          </a:bodyPr>
-          <a:lstStyle/>
-          <a:p>
-            <a:pPr algn="l">
-              <a:lnSpc>
-                <a:spcPct val="100000"/>
-              </a:lnSpc>
-              <a:spcAft>
-                <a:spcPts val="600"/>
-              </a:spcAft>
-            </a:pPr>
-            <a:r>
-              <a:rPr sz="1150" b="0" i="0">
+              <a:rPr sz="1200" b="0" i="0">
                 <a:solidFill>
                   <a:srgbClr val="1C2430"/>
                 </a:solidFill>
                 <a:latin typeface="Roboto"/>
               </a:rPr>
-              <a:t>Your security team + ours · define success criteria</a:t>
-            </a:r>
-          </a:p>
-        </p:txBody>
-      </p:sp>
-      <p:sp>
-        <p:nvSpPr>
-          <p:cNvPr id="19" name="Rounded Rectangle 18"/>
+              <a:t>Your security team + ours · access to one real repo · success criteria you define</a:t>
+            </a:r>
+          </a:p>
+        </p:txBody>
+      </p:sp>
+      <p:sp>
+        <p:nvSpPr>
+          <p:cNvPr id="17" name="Rounded Rectangle 16"/>
           <p:cNvSpPr/>
           <p:nvPr/>
         </p:nvSpPr>
         <p:spPr>
           <a:xfrm>
-            <a:off x="502920" y="3529584"/>
-            <a:ext cx="11201400" cy="932688"/>
+            <a:off x="502920" y="3931920"/>
+            <a:ext cx="11201400" cy="1115568"/>
           </a:xfrm>
           <a:prstGeom prst="roundRect">
             <a:avLst>
@@ -7043,14 +6997,14 @@
       </p:sp>
       <p:sp>
         <p:nvSpPr>
-          <p:cNvPr id="20" name="Oval 19"/>
+          <p:cNvPr id="18" name="Oval 17"/>
           <p:cNvSpPr/>
           <p:nvPr/>
         </p:nvSpPr>
         <p:spPr>
           <a:xfrm>
-            <a:off x="658368" y="3730752"/>
-            <a:ext cx="530352" cy="530352"/>
+            <a:off x="713232" y="4206240"/>
+            <a:ext cx="566928" cy="566928"/>
           </a:xfrm>
           <a:prstGeom prst="ellipse">
             <a:avLst/>
@@ -7087,14 +7041,14 @@
       </p:sp>
       <p:sp>
         <p:nvSpPr>
-          <p:cNvPr id="21" name="TextBox 20"/>
+          <p:cNvPr id="19" name="TextBox 18"/>
           <p:cNvSpPr txBox="1"/>
           <p:nvPr/>
         </p:nvSpPr>
         <p:spPr>
           <a:xfrm>
-            <a:off x="658368" y="3803904"/>
-            <a:ext cx="530352" cy="402336"/>
+            <a:off x="713232" y="4270248"/>
+            <a:ext cx="566928" cy="438912"/>
           </a:xfrm>
           <a:prstGeom prst="rect">
             <a:avLst/>
@@ -7116,7 +7070,7 @@
               </a:spcAft>
             </a:pPr>
             <a:r>
-              <a:rPr sz="1700" b="1" i="0">
+              <a:rPr sz="1800" b="1" i="0">
                 <a:solidFill>
                   <a:srgbClr val="FFFFFF"/>
                 </a:solidFill>
@@ -7129,14 +7083,14 @@
       </p:sp>
       <p:sp>
         <p:nvSpPr>
-          <p:cNvPr id="22" name="TextBox 21"/>
+          <p:cNvPr id="20" name="TextBox 19"/>
           <p:cNvSpPr txBox="1"/>
           <p:nvPr/>
         </p:nvSpPr>
         <p:spPr>
           <a:xfrm>
-            <a:off x="1417320" y="3639312"/>
-            <a:ext cx="1417320" cy="685800"/>
+            <a:off x="1508760" y="3931920"/>
+            <a:ext cx="1417320" cy="1115568"/>
           </a:xfrm>
           <a:prstGeom prst="rect">
             <a:avLst/>
@@ -7144,7 +7098,7 @@
           <a:noFill/>
         </p:spPr>
         <p:txBody>
-          <a:bodyPr wrap="square" anchor="t">
+          <a:bodyPr wrap="square" anchor="ctr">
             <a:spAutoFit/>
           </a:bodyPr>
           <a:lstStyle/>
@@ -7158,7 +7112,7 @@
               </a:spcAft>
             </a:pPr>
             <a:r>
-              <a:rPr sz="1150" b="1" i="0">
+              <a:rPr sz="1200" b="1" i="0">
                 <a:solidFill>
                   <a:srgbClr val="E31837"/>
                 </a:solidFill>
@@ -7171,14 +7125,14 @@
       </p:sp>
       <p:sp>
         <p:nvSpPr>
-          <p:cNvPr id="23" name="TextBox 22"/>
+          <p:cNvPr id="21" name="TextBox 20"/>
           <p:cNvSpPr txBox="1"/>
           <p:nvPr/>
         </p:nvSpPr>
         <p:spPr>
           <a:xfrm>
-            <a:off x="2834640" y="3639312"/>
-            <a:ext cx="8595360" cy="365760"/>
+            <a:off x="3017520" y="3931920"/>
+            <a:ext cx="8503920" cy="1115568"/>
           </a:xfrm>
           <a:prstGeom prst="rect">
             <a:avLst/>
@@ -7186,7 +7140,7 @@
           <a:noFill/>
         </p:spPr>
         <p:txBody>
-          <a:bodyPr wrap="square" anchor="t">
+          <a:bodyPr wrap="square" anchor="ctr">
             <a:spAutoFit/>
           </a:bodyPr>
           <a:lstStyle/>
@@ -7200,38 +7154,15 @@
               </a:spcAft>
             </a:pPr>
             <a:r>
-              <a:rPr sz="1450" b="1" i="0">
+              <a:rPr sz="1600" b="1" i="0">
                 <a:solidFill>
                   <a:srgbClr val="012169"/>
                 </a:solidFill>
                 <a:latin typeface="Roboto"/>
               </a:rPr>
-              <a:t>Run a pilot for you</a:t>
-            </a:r>
-          </a:p>
-        </p:txBody>
-      </p:sp>
-      <p:sp>
-        <p:nvSpPr>
-          <p:cNvPr id="24" name="TextBox 23"/>
-          <p:cNvSpPr txBox="1"/>
-          <p:nvPr/>
-        </p:nvSpPr>
-        <p:spPr>
-          <a:xfrm>
-            <a:off x="2834640" y="3986784"/>
-            <a:ext cx="8595360" cy="411480"/>
-          </a:xfrm>
-          <a:prstGeom prst="rect">
-            <a:avLst/>
-          </a:prstGeom>
-          <a:noFill/>
-        </p:spPr>
-        <p:txBody>
-          <a:bodyPr wrap="square" anchor="t">
-            <a:spAutoFit/>
-          </a:bodyPr>
-          <a:lstStyle/>
+              <a:t>Devin migrates your shared library</a:t>
+            </a:r>
+          </a:p>
           <a:p>
             <a:pPr algn="l">
               <a:lnSpc>
@@ -7242,27 +7173,27 @@
               </a:spcAft>
             </a:pPr>
             <a:r>
-              <a:rPr sz="1150" b="0" i="0">
+              <a:rPr sz="1200" b="0" i="0">
                 <a:solidFill>
                   <a:srgbClr val="1C2430"/>
                 </a:solidFill>
                 <a:latin typeface="Roboto"/>
               </a:rPr>
-              <a:t>Devin works one real use case; your engineers review; we measure</a:t>
-            </a:r>
-          </a:p>
-        </p:txBody>
-      </p:sp>
-      <p:sp>
-        <p:nvSpPr>
-          <p:cNvPr id="25" name="Rounded Rectangle 24"/>
+              <a:t>Real code, 14 → 18 — your engineers review every PR</a:t>
+            </a:r>
+          </a:p>
+        </p:txBody>
+      </p:sp>
+      <p:sp>
+        <p:nvSpPr>
+          <p:cNvPr id="22" name="Rounded Rectangle 21"/>
           <p:cNvSpPr/>
           <p:nvPr/>
         </p:nvSpPr>
         <p:spPr>
           <a:xfrm>
-            <a:off x="502920" y="4553712"/>
-            <a:ext cx="11201400" cy="932688"/>
+            <a:off x="502920" y="5175504"/>
+            <a:ext cx="11201400" cy="1115568"/>
           </a:xfrm>
           <a:prstGeom prst="roundRect">
             <a:avLst>
@@ -7301,14 +7232,14 @@
       </p:sp>
       <p:sp>
         <p:nvSpPr>
-          <p:cNvPr id="26" name="Oval 25"/>
+          <p:cNvPr id="23" name="Oval 22"/>
           <p:cNvSpPr/>
           <p:nvPr/>
         </p:nvSpPr>
         <p:spPr>
           <a:xfrm>
-            <a:off x="658368" y="4754880"/>
-            <a:ext cx="530352" cy="530352"/>
+            <a:off x="713232" y="5449824"/>
+            <a:ext cx="566928" cy="566928"/>
           </a:xfrm>
           <a:prstGeom prst="ellipse">
             <a:avLst/>
@@ -7345,14 +7276,14 @@
       </p:sp>
       <p:sp>
         <p:nvSpPr>
-          <p:cNvPr id="27" name="TextBox 26"/>
+          <p:cNvPr id="24" name="TextBox 23"/>
           <p:cNvSpPr txBox="1"/>
           <p:nvPr/>
         </p:nvSpPr>
         <p:spPr>
           <a:xfrm>
-            <a:off x="658368" y="4828032"/>
-            <a:ext cx="530352" cy="402336"/>
+            <a:off x="713232" y="5513832"/>
+            <a:ext cx="566928" cy="438912"/>
           </a:xfrm>
           <a:prstGeom prst="rect">
             <a:avLst/>
@@ -7374,7 +7305,7 @@
               </a:spcAft>
             </a:pPr>
             <a:r>
-              <a:rPr sz="1700" b="1" i="0">
+              <a:rPr sz="1800" b="1" i="0">
                 <a:solidFill>
                   <a:srgbClr val="FFFFFF"/>
                 </a:solidFill>
@@ -7387,14 +7318,14 @@
       </p:sp>
       <p:sp>
         <p:nvSpPr>
-          <p:cNvPr id="28" name="TextBox 27"/>
+          <p:cNvPr id="25" name="TextBox 24"/>
           <p:cNvSpPr txBox="1"/>
           <p:nvPr/>
         </p:nvSpPr>
         <p:spPr>
           <a:xfrm>
-            <a:off x="1417320" y="4663440"/>
-            <a:ext cx="1417320" cy="685800"/>
+            <a:off x="1508760" y="5175504"/>
+            <a:ext cx="1417320" cy="1115568"/>
           </a:xfrm>
           <a:prstGeom prst="rect">
             <a:avLst/>
@@ -7402,7 +7333,7 @@
           <a:noFill/>
         </p:spPr>
         <p:txBody>
-          <a:bodyPr wrap="square" anchor="t">
+          <a:bodyPr wrap="square" anchor="ctr">
             <a:spAutoFit/>
           </a:bodyPr>
           <a:lstStyle/>
@@ -7416,7 +7347,7 @@
               </a:spcAft>
             </a:pPr>
             <a:r>
-              <a:rPr sz="1150" b="1" i="0">
+              <a:rPr sz="1200" b="1" i="0">
                 <a:solidFill>
                   <a:srgbClr val="E31837"/>
                 </a:solidFill>
@@ -7429,14 +7360,14 @@
       </p:sp>
       <p:sp>
         <p:nvSpPr>
-          <p:cNvPr id="29" name="TextBox 28"/>
+          <p:cNvPr id="26" name="TextBox 25"/>
           <p:cNvSpPr txBox="1"/>
           <p:nvPr/>
         </p:nvSpPr>
         <p:spPr>
           <a:xfrm>
-            <a:off x="2834640" y="4663440"/>
-            <a:ext cx="8595360" cy="365760"/>
+            <a:off x="3017520" y="5175504"/>
+            <a:ext cx="8503920" cy="1115568"/>
           </a:xfrm>
           <a:prstGeom prst="rect">
             <a:avLst/>
@@ -7444,7 +7375,7 @@
           <a:noFill/>
         </p:spPr>
         <p:txBody>
-          <a:bodyPr wrap="square" anchor="t">
+          <a:bodyPr wrap="square" anchor="ctr">
             <a:spAutoFit/>
           </a:bodyPr>
           <a:lstStyle/>
@@ -7458,7 +7389,7 @@
               </a:spcAft>
             </a:pPr>
             <a:r>
-              <a:rPr sz="1450" b="1" i="0">
+              <a:rPr sz="1600" b="1" i="0">
                 <a:solidFill>
                   <a:srgbClr val="012169"/>
                 </a:solidFill>
@@ -7467,29 +7398,6 @@
               <a:t>Go / no-go readout</a:t>
             </a:r>
           </a:p>
-        </p:txBody>
-      </p:sp>
-      <p:sp>
-        <p:nvSpPr>
-          <p:cNvPr id="30" name="TextBox 29"/>
-          <p:cNvSpPr txBox="1"/>
-          <p:nvPr/>
-        </p:nvSpPr>
-        <p:spPr>
-          <a:xfrm>
-            <a:off x="2834640" y="5010912"/>
-            <a:ext cx="8595360" cy="411480"/>
-          </a:xfrm>
-          <a:prstGeom prst="rect">
-            <a:avLst/>
-          </a:prstGeom>
-          <a:noFill/>
-        </p:spPr>
-        <p:txBody>
-          <a:bodyPr wrap="square" anchor="t">
-            <a:spAutoFit/>
-          </a:bodyPr>
-          <a:lstStyle/>
           <a:p>
             <a:pPr algn="l">
               <a:lnSpc>
@@ -7500,71 +7408,20 @@
               </a:spcAft>
             </a:pPr>
             <a:r>
-              <a:rPr sz="1150" b="0" i="0">
+              <a:rPr sz="1200" b="0" i="0">
                 <a:solidFill>
                   <a:srgbClr val="1C2430"/>
                 </a:solidFill>
                 <a:latin typeface="Roboto"/>
               </a:rPr>
-              <a:t>Results in front of this room — then scale to the other two</a:t>
-            </a:r>
-          </a:p>
-        </p:txBody>
-      </p:sp>
-      <p:sp>
-        <p:nvSpPr>
-          <p:cNvPr id="31" name="TextBox 30"/>
-          <p:cNvSpPr txBox="1"/>
-          <p:nvPr/>
-        </p:nvSpPr>
-        <p:spPr>
-          <a:xfrm>
-            <a:off x="502920" y="5715000"/>
-            <a:ext cx="11201400" cy="548640"/>
-          </a:xfrm>
-          <a:prstGeom prst="rect">
-            <a:avLst/>
-          </a:prstGeom>
-          <a:noFill/>
-        </p:spPr>
-        <p:txBody>
-          <a:bodyPr wrap="square" anchor="t">
-            <a:spAutoFit/>
-          </a:bodyPr>
-          <a:lstStyle/>
-          <a:p>
-            <a:pPr algn="l">
-              <a:lnSpc>
-                <a:spcPct val="100000"/>
-              </a:lnSpc>
-              <a:spcAft>
-                <a:spcPts val="600"/>
-              </a:spcAft>
-            </a:pPr>
-            <a:r>
-              <a:rPr sz="1400" b="1" i="0">
-                <a:solidFill>
-                  <a:srgbClr val="E31837"/>
-                </a:solidFill>
-                <a:latin typeface="Roboto"/>
-              </a:rPr>
-              <a:t>The ask:  </a:t>
-            </a:r>
-            <a:r>
-              <a:rPr sz="1400" b="1" i="0">
-                <a:solidFill>
-                  <a:srgbClr val="012169"/>
-                </a:solidFill>
-                <a:latin typeface="Roboto"/>
-              </a:rPr>
-              <a:t>three use cases, one pilot, four weeks, your success criteria.</a:t>
-            </a:r>
-          </a:p>
-        </p:txBody>
-      </p:sp>
-      <p:sp>
-        <p:nvSpPr>
-          <p:cNvPr id="32" name="TextBox 31"/>
+              <a:t>Results in front of this room — then downstream apps in parallel</a:t>
+            </a:r>
+          </a:p>
+        </p:txBody>
+      </p:sp>
+      <p:sp>
+        <p:nvSpPr>
+          <p:cNvPr id="27" name="TextBox 26"/>
           <p:cNvSpPr txBox="1"/>
           <p:nvPr/>
         </p:nvSpPr>

</xml_diff>

<commit_message>
Restructure next steps: pick what to test, pilot, readout, full deployment
Co-Authored-By: Devin AI <158243242+devin-ai-integration[bot]@users.noreply.github.com>
</commit_message>
<xml_diff>
--- a/presentation/BofA_x_Cognition_Devin_Demo.pptx
+++ b/presentation/BofA_x_Cognition_Devin_Demo.pptx
@@ -722,7 +722,7 @@
           <a:p/>
           <a:p>
             <a:r>
-              <a:t>Talk track: "You just watched the proof of concept — now let's do it for real. Step one, we scope your actual Angular estate together: which repos are on 14, where the shared library sits, who consumes it downstream. Step two, a security and data review so your team is comfortable, and we agree the success criteria up front. Then weeks two to four: Devin migrates your real shared library, 14 to 18, and your engineers review every PR — same thing you saw today, on your code. Week four, we're back in this room with results, and if it earned its keep, we point Devin at the downstream apps in parallel. If it didn't, you've spent four weeks finding out."</a:t>
+              <a:t>Talk track: "You just watched the proof of concept — now let's do it for real, in four simple beats. One: we pick what to test — which slice of your Angular 14 estate Devin starts on; the shared library is the natural first pick, but it's your call. Two: the pilot phase — a quick security and data review, then Devin migrates real code, 14 to 18, with your engineers reviewing every PR, same as you saw today. Three: we see how it did — back in this room at week four, measured against success criteria you defined up front. Four: if it earned its keep, we deploy Devin fully — downstream apps in parallel, then the rest of the maintenance backlog. If it didn't, you've spent four weeks finding out."</a:t>
             </a:r>
           </a:p>
           <a:p/>
@@ -6690,7 +6690,7 @@
                 </a:solidFill>
                 <a:latin typeface="Roboto"/>
               </a:rPr>
-              <a:t>Scope your Angular estate</a:t>
+              <a:t>Pick what to test</a:t>
             </a:r>
           </a:p>
           <a:p>
@@ -6709,7 +6709,7 @@
                 </a:solidFill>
                 <a:latin typeface="Roboto"/>
               </a:rPr>
-              <a:t>Inventory the 14.x repos — shared library, downstream consumers, test coverage</a:t>
+              <a:t>Choose the Angular 14.x slice Devin starts on — the shared library is the natural first pick</a:t>
             </a:r>
           </a:p>
         </p:txBody>
@@ -6883,7 +6883,7 @@
                 </a:solidFill>
                 <a:latin typeface="Roboto"/>
               </a:rPr>
-              <a:t>Next week</a:t>
+              <a:t>Weeks 1–4</a:t>
             </a:r>
           </a:p>
         </p:txBody>
@@ -6925,7 +6925,7 @@
                 </a:solidFill>
                 <a:latin typeface="Roboto"/>
               </a:rPr>
-              <a:t>Security &amp; data review</a:t>
+              <a:t>Pilot phase</a:t>
             </a:r>
           </a:p>
           <a:p>
@@ -6944,7 +6944,7 @@
                 </a:solidFill>
                 <a:latin typeface="Roboto"/>
               </a:rPr>
-              <a:t>Your security team + ours · access to one real repo · success criteria you define</a:t>
+              <a:t>Security review, then Devin migrates real code 14 → 18 — your engineers review every PR</a:t>
             </a:r>
           </a:p>
         </p:txBody>
@@ -7118,7 +7118,7 @@
                 </a:solidFill>
                 <a:latin typeface="Roboto"/>
               </a:rPr>
-              <a:t>Weeks 2–4</a:t>
+              <a:t>Week 4</a:t>
             </a:r>
           </a:p>
         </p:txBody>
@@ -7160,7 +7160,7 @@
                 </a:solidFill>
                 <a:latin typeface="Roboto"/>
               </a:rPr>
-              <a:t>Devin migrates your shared library</a:t>
+              <a:t>See how it does</a:t>
             </a:r>
           </a:p>
           <a:p>
@@ -7179,7 +7179,7 @@
                 </a:solidFill>
                 <a:latin typeface="Roboto"/>
               </a:rPr>
-              <a:t>Real code, 14 → 18 — your engineers review every PR</a:t>
+              <a:t>Readout against your success criteria, in front of this room</a:t>
             </a:r>
           </a:p>
         </p:txBody>
@@ -7353,7 +7353,7 @@
                 </a:solidFill>
                 <a:latin typeface="Roboto"/>
               </a:rPr>
-              <a:t>Week 4</a:t>
+              <a:t>After</a:t>
             </a:r>
           </a:p>
         </p:txBody>
@@ -7395,7 +7395,7 @@
                 </a:solidFill>
                 <a:latin typeface="Roboto"/>
               </a:rPr>
-              <a:t>Go / no-go readout</a:t>
+              <a:t>Deploy Devin fully</a:t>
             </a:r>
           </a:p>
           <a:p>
@@ -7414,7 +7414,7 @@
                 </a:solidFill>
                 <a:latin typeface="Roboto"/>
               </a:rPr>
-              <a:t>Results in front of this room — then downstream apps in parallel</a:t>
+              <a:t>Downstream apps in parallel — then the rest of the maintenance backlog</a:t>
             </a:r>
           </a:p>
         </p:txBody>

</xml_diff>

<commit_message>
Next steps: pick 3 Angular apps together as step 1
</commit_message>
<xml_diff>
--- a/presentation/BofA_x_Cognition_Devin_Demo.pptx
+++ b/presentation/BofA_x_Cognition_Devin_Demo.pptx
@@ -722,19 +722,19 @@
           <a:p/>
           <a:p>
             <a:r>
-              <a:t>Talk track: "You just watched the proof of concept — now let's do it for real, in four simple beats. One: we pick what to test — which slice of your Angular 14 estate Devin starts on; the shared library is the natural first pick, but it's your call. Two: the pilot phase — a quick security and data review, then Devin migrates real code, 14 to 18, with your engineers reviewing every PR, same as you saw today. Three: we see how it did — back in this room at week four, measured against success criteria you defined up front. Four: if it earned its keep, we deploy Devin fully — downstream apps in parallel, then the rest of the maintenance backlog. If it didn't, you've spent four weeks finding out."</a:t>
+              <a:t>Talk track: "You just watched the proof of concept — now let's do it for real, in four simple beats. One: we sit down with your team and pick three Angular 14 apps for Devin to fix — you know which ones hurt the most; a mix of a lower-stakes app and something meaty like the shared library works well. Two: the pilot phase — a quick security and data review, then Devin migrates that real code, 14 to 18, with your engineers reviewing every PR, same as you saw today. Three: we see how it did — back in this room at week four, measured against success criteria you defined up front. Four: if it earned its keep, we deploy Devin fully — the rest of the Angular estate in parallel, then the broader maintenance backlog. If it didn't, you've spent four weeks finding out."</a:t>
             </a:r>
           </a:p>
           <a:p/>
           <a:p>
             <a:r>
-              <a:t>Why the shared library as the pilot slice: it's the root of the dependency tree — proving it there de-risks everything downstream, and it's the exact shape of what they saw in the demo. If they'd rather start on a lower-stakes repo, flex immediately; the structure holds.</a:t>
+              <a:t>Why three apps: one app feels like a science experiment; three makes it a representative sample — and gets them invested in a roadmap. Steer the mix: one low-stakes, one typical, one hard (e.g. the shared library). If they push to start with just one, flex immediately; the structure holds.</a:t>
             </a:r>
           </a:p>
           <a:p/>
           <a:p>
             <a:r>
-              <a:t>Assign ownership live: estate scoping → Chief Architect (they know the dependency tree); security review → Security Engineer; sponsorship + success criteria → VP Eng. People who own a step show up to the next meeting.</a:t>
+              <a:t>Assign ownership live: the three-app shortlist → Chief Architect (they know the dependency tree); security review → Security Engineer; sponsorship + success criteria → VP Eng. People who own a step show up to the next meeting.</a:t>
             </a:r>
           </a:p>
           <a:p/>
@@ -6690,7 +6690,7 @@
                 </a:solidFill>
                 <a:latin typeface="Roboto"/>
               </a:rPr>
-              <a:t>Pick what to test</a:t>
+              <a:t>Pick 3 Angular apps together</a:t>
             </a:r>
           </a:p>
           <a:p>
@@ -6709,7 +6709,7 @@
                 </a:solidFill>
                 <a:latin typeface="Roboto"/>
               </a:rPr>
-              <a:t>Choose the Angular 14.x slice Devin starts on — the shared library is the natural first pick</a:t>
+              <a:t>We sit down with your team and choose three 14.x apps for Devin to fix</a:t>
             </a:r>
           </a:p>
         </p:txBody>
@@ -7414,7 +7414,7 @@
                 </a:solidFill>
                 <a:latin typeface="Roboto"/>
               </a:rPr>
-              <a:t>Downstream apps in parallel — then the rest of the maintenance backlog</a:t>
+              <a:t>Rest of the Angular estate in parallel — then the broader maintenance backlog</a:t>
             </a:r>
           </a:p>
         </p:txBody>

</xml_diff>

<commit_message>
Redesign end-state slide as today/with-Devin split; finalize next-steps subheadings
Co-Authored-By: Devin AI <158243242+devin-ai-integration[bot]@users.noreply.github.com>
</commit_message>
<xml_diff>
--- a/presentation/BofA_x_Cognition_Devin_Demo.pptx
+++ b/presentation/BofA_x_Cognition_Devin_Demo.pptx
@@ -5472,7 +5472,7 @@
                 </a:solidFill>
                 <a:latin typeface="Roboto"/>
               </a:rPr>
-              <a:t>The end state: BofA running on Devin</a:t>
+              <a:t>The future of Bank of America engineering</a:t>
             </a:r>
           </a:p>
         </p:txBody>
@@ -5528,7 +5528,7 @@
         <p:spPr>
           <a:xfrm>
             <a:off x="502920" y="1481328"/>
-            <a:ext cx="3611880" cy="2286000"/>
+            <a:ext cx="5257800" cy="4572000"/>
           </a:xfrm>
           <a:prstGeom prst="roundRect">
             <a:avLst>
@@ -5567,16 +5567,214 @@
       </p:sp>
       <p:sp>
         <p:nvSpPr>
-          <p:cNvPr id="8" name="Rectangle 7"/>
+          <p:cNvPr id="8" name="TextBox 7"/>
+          <p:cNvSpPr txBox="1"/>
+          <p:nvPr/>
+        </p:nvSpPr>
+        <p:spPr>
+          <a:xfrm>
+            <a:off x="868680" y="1755648"/>
+            <a:ext cx="4572000" cy="457200"/>
+          </a:xfrm>
+          <a:prstGeom prst="rect">
+            <a:avLst/>
+          </a:prstGeom>
+          <a:noFill/>
+        </p:spPr>
+        <p:txBody>
+          <a:bodyPr wrap="square" anchor="t">
+            <a:spAutoFit/>
+          </a:bodyPr>
+          <a:lstStyle/>
+          <a:p>
+            <a:pPr algn="l">
+              <a:lnSpc>
+                <a:spcPct val="100000"/>
+              </a:lnSpc>
+              <a:spcAft>
+                <a:spcPts val="600"/>
+              </a:spcAft>
+            </a:pPr>
+            <a:r>
+              <a:rPr sz="1300" b="1" i="0">
+                <a:solidFill>
+                  <a:srgbClr val="5A6472"/>
+                </a:solidFill>
+                <a:latin typeface="Roboto"/>
+              </a:rPr>
+              <a:t>TODAY</a:t>
+            </a:r>
+          </a:p>
+        </p:txBody>
+      </p:sp>
+      <p:sp>
+        <p:nvSpPr>
+          <p:cNvPr id="9" name="TextBox 8"/>
+          <p:cNvSpPr txBox="1"/>
+          <p:nvPr/>
+        </p:nvSpPr>
+        <p:spPr>
+          <a:xfrm>
+            <a:off x="868680" y="2514600"/>
+            <a:ext cx="4572000" cy="3291840"/>
+          </a:xfrm>
+          <a:prstGeom prst="rect">
+            <a:avLst/>
+          </a:prstGeom>
+          <a:noFill/>
+        </p:spPr>
+        <p:txBody>
+          <a:bodyPr wrap="square" anchor="t">
+            <a:spAutoFit/>
+          </a:bodyPr>
+          <a:lstStyle/>
+          <a:p>
+            <a:pPr algn="l">
+              <a:lnSpc>
+                <a:spcPct val="100000"/>
+              </a:lnSpc>
+              <a:spcAft>
+                <a:spcPts val="600"/>
+              </a:spcAft>
+            </a:pPr>
+            <a:r>
+              <a:rPr sz="1500" b="0" i="0">
+                <a:solidFill>
+                  <a:srgbClr val="1C2430"/>
+                </a:solidFill>
+                <a:latin typeface="Roboto"/>
+              </a:rPr>
+              <a:t>~70% of tech budget on maintenance</a:t>
+            </a:r>
+          </a:p>
+          <a:p>
+            <a:pPr algn="l">
+              <a:lnSpc>
+                <a:spcPct val="100000"/>
+              </a:lnSpc>
+              <a:spcAft>
+                <a:spcPts val="600"/>
+              </a:spcAft>
+            </a:pPr>
+            <a:r>
+              <a:rPr sz="3000" b="0" i="0">
+                <a:solidFill>
+                  <a:srgbClr val="1C2430"/>
+                </a:solidFill>
+                <a:latin typeface="Roboto"/>
+              </a:rPr>
+              <a:t/>
+            </a:r>
+          </a:p>
+          <a:p>
+            <a:pPr algn="l">
+              <a:lnSpc>
+                <a:spcPct val="100000"/>
+              </a:lnSpc>
+              <a:spcAft>
+                <a:spcPts val="600"/>
+              </a:spcAft>
+            </a:pPr>
+            <a:r>
+              <a:rPr sz="1500" b="0" i="0">
+                <a:solidFill>
+                  <a:srgbClr val="1C2430"/>
+                </a:solidFill>
+                <a:latin typeface="Roboto"/>
+              </a:rPr>
+              <a:t>Compliance deadlines displace the roadmap</a:t>
+            </a:r>
+          </a:p>
+          <a:p>
+            <a:pPr algn="l">
+              <a:lnSpc>
+                <a:spcPct val="100000"/>
+              </a:lnSpc>
+              <a:spcAft>
+                <a:spcPts val="600"/>
+              </a:spcAft>
+            </a:pPr>
+            <a:r>
+              <a:rPr sz="3000" b="0" i="0">
+                <a:solidFill>
+                  <a:srgbClr val="1C2430"/>
+                </a:solidFill>
+                <a:latin typeface="Roboto"/>
+              </a:rPr>
+              <a:t/>
+            </a:r>
+          </a:p>
+          <a:p>
+            <a:pPr algn="l">
+              <a:lnSpc>
+                <a:spcPct val="100000"/>
+              </a:lnSpc>
+              <a:spcAft>
+                <a:spcPts val="600"/>
+              </a:spcAft>
+            </a:pPr>
+            <a:r>
+              <a:rPr sz="1500" b="0" i="0">
+                <a:solidFill>
+                  <a:srgbClr val="1C2430"/>
+                </a:solidFill>
+                <a:latin typeface="Roboto"/>
+              </a:rPr>
+              <a:t>Best engineers stuck on migrations &amp; upkeep</a:t>
+            </a:r>
+          </a:p>
+          <a:p>
+            <a:pPr algn="l">
+              <a:lnSpc>
+                <a:spcPct val="100000"/>
+              </a:lnSpc>
+              <a:spcAft>
+                <a:spcPts val="600"/>
+              </a:spcAft>
+            </a:pPr>
+            <a:r>
+              <a:rPr sz="3000" b="0" i="0">
+                <a:solidFill>
+                  <a:srgbClr val="1C2430"/>
+                </a:solidFill>
+                <a:latin typeface="Roboto"/>
+              </a:rPr>
+              <a:t/>
+            </a:r>
+          </a:p>
+          <a:p>
+            <a:pPr algn="l">
+              <a:lnSpc>
+                <a:spcPct val="100000"/>
+              </a:lnSpc>
+              <a:spcAft>
+                <a:spcPts val="600"/>
+              </a:spcAft>
+            </a:pPr>
+            <a:r>
+              <a:rPr sz="1500" b="0" i="0">
+                <a:solidFill>
+                  <a:srgbClr val="1C2430"/>
+                </a:solidFill>
+                <a:latin typeface="Roboto"/>
+              </a:rPr>
+              <a:t>Legacy debt compounds, quarter after quarter</a:t>
+            </a:r>
+          </a:p>
+        </p:txBody>
+      </p:sp>
+      <p:sp>
+        <p:nvSpPr>
+          <p:cNvPr id="10" name="Chevron 9"/>
           <p:cNvSpPr/>
           <p:nvPr/>
         </p:nvSpPr>
         <p:spPr>
           <a:xfrm>
-            <a:off x="502920" y="1591056"/>
-            <a:ext cx="54864" cy="2066543"/>
-          </a:xfrm>
-          <a:prstGeom prst="rect">
+            <a:off x="5870448" y="3401568"/>
+            <a:ext cx="457200" cy="731520"/>
+          </a:xfrm>
+          <a:prstGeom prst="chevron">
             <a:avLst/>
           </a:prstGeom>
           <a:solidFill>
@@ -5611,136 +5809,14 @@
       </p:sp>
       <p:sp>
         <p:nvSpPr>
-          <p:cNvPr id="9" name="TextBox 8"/>
-          <p:cNvSpPr txBox="1"/>
-          <p:nvPr/>
-        </p:nvSpPr>
-        <p:spPr>
-          <a:xfrm>
-            <a:off x="704088" y="1591056"/>
-            <a:ext cx="3246120" cy="365760"/>
-          </a:xfrm>
-          <a:prstGeom prst="rect">
-            <a:avLst/>
-          </a:prstGeom>
-          <a:noFill/>
-        </p:spPr>
-        <p:txBody>
-          <a:bodyPr wrap="square" anchor="t">
-            <a:spAutoFit/>
-          </a:bodyPr>
-          <a:lstStyle/>
-          <a:p>
-            <a:pPr algn="l">
-              <a:lnSpc>
-                <a:spcPct val="100000"/>
-              </a:lnSpc>
-              <a:spcAft>
-                <a:spcPts val="600"/>
-              </a:spcAft>
-            </a:pPr>
-            <a:r>
-              <a:rPr sz="1400" b="1" i="0">
-                <a:solidFill>
-                  <a:srgbClr val="012169"/>
-                </a:solidFill>
-                <a:latin typeface="Roboto"/>
-              </a:rPr>
-              <a:t>This migration</a:t>
-            </a:r>
-          </a:p>
-        </p:txBody>
-      </p:sp>
-      <p:sp>
-        <p:nvSpPr>
-          <p:cNvPr id="10" name="TextBox 9"/>
-          <p:cNvSpPr txBox="1"/>
-          <p:nvPr/>
-        </p:nvSpPr>
-        <p:spPr>
-          <a:xfrm>
-            <a:off x="704088" y="1956816"/>
-            <a:ext cx="3246120" cy="1691640"/>
-          </a:xfrm>
-          <a:prstGeom prst="rect">
-            <a:avLst/>
-          </a:prstGeom>
-          <a:noFill/>
-        </p:spPr>
-        <p:txBody>
-          <a:bodyPr wrap="square" anchor="t">
-            <a:spAutoFit/>
-          </a:bodyPr>
-          <a:lstStyle/>
-          <a:p>
-            <a:pPr algn="l">
-              <a:lnSpc>
-                <a:spcPct val="105000"/>
-              </a:lnSpc>
-              <a:spcAft>
-                <a:spcPts val="500"/>
-              </a:spcAft>
-            </a:pPr>
-            <a:r>
-              <a:rPr sz="1400" b="0" i="0">
-                <a:solidFill>
-                  <a:srgbClr val="1C2430"/>
-                </a:solidFill>
-                <a:latin typeface="Roboto"/>
-              </a:rPr>
-              <a:t>Angular 18 before the deadline</a:t>
-            </a:r>
-          </a:p>
-          <a:p>
-            <a:pPr algn="l">
-              <a:lnSpc>
-                <a:spcPct val="105000"/>
-              </a:lnSpc>
-              <a:spcAft>
-                <a:spcPts val="500"/>
-              </a:spcAft>
-            </a:pPr>
-            <a:r>
-              <a:rPr sz="1400" b="0" i="0">
-                <a:solidFill>
-                  <a:srgbClr val="1C2430"/>
-                </a:solidFill>
-                <a:latin typeface="Roboto"/>
-              </a:rPr>
-              <a:t>12+ teams unbroken</a:t>
-            </a:r>
-          </a:p>
-          <a:p>
-            <a:pPr algn="l">
-              <a:lnSpc>
-                <a:spcPct val="105000"/>
-              </a:lnSpc>
-              <a:spcAft>
-                <a:spcPts val="500"/>
-              </a:spcAft>
-            </a:pPr>
-            <a:r>
-              <a:rPr sz="1400" b="0" i="0">
-                <a:solidFill>
-                  <a:srgbClr val="1C2430"/>
-                </a:solidFill>
-                <a:latin typeface="Roboto"/>
-              </a:rPr>
-              <a:t>Audit trail, automatic</a:t>
-            </a:r>
-          </a:p>
-        </p:txBody>
-      </p:sp>
-      <p:sp>
-        <p:nvSpPr>
           <p:cNvPr id="11" name="Rounded Rectangle 10"/>
           <p:cNvSpPr/>
           <p:nvPr/>
         </p:nvSpPr>
         <p:spPr>
           <a:xfrm>
-            <a:off x="4297680" y="1481328"/>
-            <a:ext cx="3611880" cy="2286000"/>
+            <a:off x="6446520" y="1481328"/>
+            <a:ext cx="5257800" cy="4572000"/>
           </a:xfrm>
           <a:prstGeom prst="roundRect">
             <a:avLst>
@@ -5748,7 +5824,7 @@
             </a:avLst>
           </a:prstGeom>
           <a:solidFill>
-            <a:srgbClr val="F4F6F9"/>
+            <a:srgbClr val="012169"/>
           </a:solidFill>
           <a:ln>
             <a:noFill/>
@@ -5779,58 +5855,14 @@
       </p:sp>
       <p:sp>
         <p:nvSpPr>
-          <p:cNvPr id="12" name="Rectangle 11"/>
-          <p:cNvSpPr/>
-          <p:nvPr/>
-        </p:nvSpPr>
-        <p:spPr>
-          <a:xfrm>
-            <a:off x="4297680" y="1591056"/>
-            <a:ext cx="54864" cy="2066543"/>
-          </a:xfrm>
-          <a:prstGeom prst="rect">
-            <a:avLst/>
-          </a:prstGeom>
-          <a:solidFill>
-            <a:srgbClr val="E31837"/>
-          </a:solidFill>
-          <a:ln>
-            <a:noFill/>
-          </a:ln>
-          <a:effectLst/>
-        </p:spPr>
-        <p:style>
-          <a:lnRef idx="1">
-            <a:schemeClr val="accent1"/>
-          </a:lnRef>
-          <a:fillRef idx="3">
-            <a:schemeClr val="accent1"/>
-          </a:fillRef>
-          <a:effectRef idx="2">
-            <a:schemeClr val="accent1"/>
-          </a:effectRef>
-          <a:fontRef idx="minor">
-            <a:schemeClr val="lt1"/>
-          </a:fontRef>
-        </p:style>
-        <p:txBody>
-          <a:bodyPr rtlCol="0" anchor="ctr"/>
-          <a:lstStyle/>
-          <a:p>
-            <a:pPr algn="ctr"/>
-          </a:p>
-        </p:txBody>
-      </p:sp>
-      <p:sp>
-        <p:nvSpPr>
-          <p:cNvPr id="13" name="TextBox 12"/>
+          <p:cNvPr id="12" name="TextBox 11"/>
           <p:cNvSpPr txBox="1"/>
           <p:nvPr/>
         </p:nvSpPr>
         <p:spPr>
           <a:xfrm>
-            <a:off x="4498848" y="1591056"/>
-            <a:ext cx="3246120" cy="365760"/>
+            <a:off x="6812280" y="1755648"/>
+            <a:ext cx="4572000" cy="457200"/>
           </a:xfrm>
           <a:prstGeom prst="rect">
             <a:avLst/>
@@ -5852,27 +5884,27 @@
               </a:spcAft>
             </a:pPr>
             <a:r>
-              <a:rPr sz="1400" b="1" i="0">
-                <a:solidFill>
-                  <a:srgbClr val="012169"/>
-                </a:solidFill>
-                <a:latin typeface="Roboto"/>
-              </a:rPr>
-              <a:t>Your engineers</a:t>
-            </a:r>
-          </a:p>
-        </p:txBody>
-      </p:sp>
-      <p:sp>
-        <p:nvSpPr>
-          <p:cNvPr id="14" name="TextBox 13"/>
+              <a:rPr sz="1300" b="1" i="0">
+                <a:solidFill>
+                  <a:srgbClr val="E31837"/>
+                </a:solidFill>
+                <a:latin typeface="Roboto"/>
+              </a:rPr>
+              <a:t>WITH DEVIN</a:t>
+            </a:r>
+          </a:p>
+        </p:txBody>
+      </p:sp>
+      <p:sp>
+        <p:nvSpPr>
+          <p:cNvPr id="13" name="TextBox 12"/>
           <p:cNvSpPr txBox="1"/>
           <p:nvPr/>
         </p:nvSpPr>
         <p:spPr>
           <a:xfrm>
-            <a:off x="4498848" y="1956816"/>
-            <a:ext cx="3246120" cy="1691640"/>
+            <a:off x="6812280" y="2514600"/>
+            <a:ext cx="4572000" cy="3291840"/>
           </a:xfrm>
           <a:prstGeom prst="rect">
             <a:avLst/>
@@ -5887,154 +5919,79 @@
           <a:p>
             <a:pPr algn="l">
               <a:lnSpc>
-                <a:spcPct val="105000"/>
-              </a:lnSpc>
-              <a:spcAft>
-                <a:spcPts val="500"/>
-              </a:spcAft>
-            </a:pPr>
-            <a:r>
-              <a:rPr sz="1400" b="0" i="0">
+                <a:spcPct val="100000"/>
+              </a:lnSpc>
+              <a:spcAft>
+                <a:spcPts val="600"/>
+              </a:spcAft>
+            </a:pPr>
+            <a:r>
+              <a:rPr sz="1500" b="0" i="0">
+                <a:solidFill>
+                  <a:srgbClr val="FFFFFF"/>
+                </a:solidFill>
+                <a:latin typeface="Roboto"/>
+              </a:rPr>
+              <a:t>Maintenance runs in the background, PR by PR</a:t>
+            </a:r>
+          </a:p>
+          <a:p>
+            <a:pPr algn="l">
+              <a:lnSpc>
+                <a:spcPct val="100000"/>
+              </a:lnSpc>
+              <a:spcAft>
+                <a:spcPts val="600"/>
+              </a:spcAft>
+            </a:pPr>
+            <a:r>
+              <a:rPr sz="3000" b="0" i="0">
                 <a:solidFill>
                   <a:srgbClr val="1C2430"/>
                 </a:solidFill>
                 <a:latin typeface="Roboto"/>
               </a:rPr>
-              <a:t>Back on revenue features</a:t>
+              <a:t/>
             </a:r>
           </a:p>
           <a:p>
             <a:pPr algn="l">
               <a:lnSpc>
-                <a:spcPct val="105000"/>
-              </a:lnSpc>
-              <a:spcAft>
-                <a:spcPts val="500"/>
-              </a:spcAft>
-            </a:pPr>
-            <a:r>
-              <a:rPr sz="1400" b="0" i="0">
+                <a:spcPct val="100000"/>
+              </a:lnSpc>
+              <a:spcAft>
+                <a:spcPts val="600"/>
+              </a:spcAft>
+            </a:pPr>
+            <a:r>
+              <a:rPr sz="1500" b="0" i="0">
+                <a:solidFill>
+                  <a:srgbClr val="FFFFFF"/>
+                </a:solidFill>
+                <a:latin typeface="Roboto"/>
+              </a:rPr>
+              <a:t>Deadlines met without pausing the roadmap</a:t>
+            </a:r>
+          </a:p>
+          <a:p>
+            <a:pPr algn="l">
+              <a:lnSpc>
+                <a:spcPct val="100000"/>
+              </a:lnSpc>
+              <a:spcAft>
+                <a:spcPts val="600"/>
+              </a:spcAft>
+            </a:pPr>
+            <a:r>
+              <a:rPr sz="3000" b="0" i="0">
                 <a:solidFill>
                   <a:srgbClr val="1C2430"/>
                 </a:solidFill>
                 <a:latin typeface="Roboto"/>
               </a:rPr>
-              <a:t>Reviewing, not hand-migrating</a:t>
-            </a:r>
-          </a:p>
-        </p:txBody>
-      </p:sp>
-      <p:sp>
-        <p:nvSpPr>
-          <p:cNvPr id="15" name="Rounded Rectangle 14"/>
-          <p:cNvSpPr/>
-          <p:nvPr/>
-        </p:nvSpPr>
-        <p:spPr>
-          <a:xfrm>
-            <a:off x="8092440" y="1481328"/>
-            <a:ext cx="3611880" cy="2286000"/>
-          </a:xfrm>
-          <a:prstGeom prst="roundRect">
-            <a:avLst>
-              <a:gd name="adj" fmla="val 6000"/>
-            </a:avLst>
-          </a:prstGeom>
-          <a:solidFill>
-            <a:srgbClr val="F4F6F9"/>
-          </a:solidFill>
-          <a:ln>
-            <a:noFill/>
-          </a:ln>
-          <a:effectLst/>
-        </p:spPr>
-        <p:style>
-          <a:lnRef idx="1">
-            <a:schemeClr val="accent1"/>
-          </a:lnRef>
-          <a:fillRef idx="3">
-            <a:schemeClr val="accent1"/>
-          </a:fillRef>
-          <a:effectRef idx="2">
-            <a:schemeClr val="accent1"/>
-          </a:effectRef>
-          <a:fontRef idx="minor">
-            <a:schemeClr val="lt1"/>
-          </a:fontRef>
-        </p:style>
-        <p:txBody>
-          <a:bodyPr rtlCol="0" anchor="ctr"/>
-          <a:lstStyle/>
-          <a:p>
-            <a:pPr algn="ctr"/>
-          </a:p>
-        </p:txBody>
-      </p:sp>
-      <p:sp>
-        <p:nvSpPr>
-          <p:cNvPr id="16" name="Rectangle 15"/>
-          <p:cNvSpPr/>
-          <p:nvPr/>
-        </p:nvSpPr>
-        <p:spPr>
-          <a:xfrm>
-            <a:off x="8092440" y="1591056"/>
-            <a:ext cx="54864" cy="2066543"/>
-          </a:xfrm>
-          <a:prstGeom prst="rect">
-            <a:avLst/>
-          </a:prstGeom>
-          <a:solidFill>
-            <a:srgbClr val="E31837"/>
-          </a:solidFill>
-          <a:ln>
-            <a:noFill/>
-          </a:ln>
-          <a:effectLst/>
-        </p:spPr>
-        <p:style>
-          <a:lnRef idx="1">
-            <a:schemeClr val="accent1"/>
-          </a:lnRef>
-          <a:fillRef idx="3">
-            <a:schemeClr val="accent1"/>
-          </a:fillRef>
-          <a:effectRef idx="2">
-            <a:schemeClr val="accent1"/>
-          </a:effectRef>
-          <a:fontRef idx="minor">
-            <a:schemeClr val="lt1"/>
-          </a:fontRef>
-        </p:style>
-        <p:txBody>
-          <a:bodyPr rtlCol="0" anchor="ctr"/>
-          <a:lstStyle/>
-          <a:p>
-            <a:pPr algn="ctr"/>
-          </a:p>
-        </p:txBody>
-      </p:sp>
-      <p:sp>
-        <p:nvSpPr>
-          <p:cNvPr id="17" name="TextBox 16"/>
-          <p:cNvSpPr txBox="1"/>
-          <p:nvPr/>
-        </p:nvSpPr>
-        <p:spPr>
-          <a:xfrm>
-            <a:off x="8293608" y="1591056"/>
-            <a:ext cx="3246120" cy="365760"/>
-          </a:xfrm>
-          <a:prstGeom prst="rect">
-            <a:avLst/>
-          </a:prstGeom>
-          <a:noFill/>
-        </p:spPr>
-        <p:txBody>
-          <a:bodyPr wrap="square" anchor="t">
-            <a:spAutoFit/>
-          </a:bodyPr>
-          <a:lstStyle/>
+              <a:t/>
+            </a:r>
+          </a:p>
           <a:p>
             <a:pPr algn="l">
               <a:lnSpc>
@@ -6045,148 +6002,37 @@
               </a:spcAft>
             </a:pPr>
             <a:r>
-              <a:rPr sz="1400" b="1" i="0">
-                <a:solidFill>
-                  <a:srgbClr val="012169"/>
-                </a:solidFill>
-                <a:latin typeface="Roboto"/>
-              </a:rPr>
-              <a:t>The bigger unlock</a:t>
-            </a:r>
-          </a:p>
-        </p:txBody>
-      </p:sp>
-      <p:sp>
-        <p:nvSpPr>
-          <p:cNvPr id="18" name="TextBox 17"/>
-          <p:cNvSpPr txBox="1"/>
-          <p:nvPr/>
-        </p:nvSpPr>
-        <p:spPr>
-          <a:xfrm>
-            <a:off x="8293608" y="1956816"/>
-            <a:ext cx="3246120" cy="1691640"/>
-          </a:xfrm>
-          <a:prstGeom prst="rect">
-            <a:avLst/>
-          </a:prstGeom>
-          <a:noFill/>
-        </p:spPr>
-        <p:txBody>
-          <a:bodyPr wrap="square" anchor="t">
-            <a:spAutoFit/>
-          </a:bodyPr>
-          <a:lstStyle/>
+              <a:rPr sz="1500" b="0" i="0">
+                <a:solidFill>
+                  <a:srgbClr val="FFFFFF"/>
+                </a:solidFill>
+                <a:latin typeface="Roboto"/>
+              </a:rPr>
+              <a:t>Engineers on greenfield and revenue work</a:t>
+            </a:r>
+          </a:p>
           <a:p>
             <a:pPr algn="l">
               <a:lnSpc>
-                <a:spcPct val="105000"/>
-              </a:lnSpc>
-              <a:spcAft>
-                <a:spcPts val="500"/>
-              </a:spcAft>
-            </a:pPr>
-            <a:r>
-              <a:rPr sz="1400" b="0" i="0">
+                <a:spcPct val="100000"/>
+              </a:lnSpc>
+              <a:spcAft>
+                <a:spcPts val="600"/>
+              </a:spcAft>
+            </a:pPr>
+            <a:r>
+              <a:rPr sz="3000" b="0" i="0">
                 <a:solidFill>
                   <a:srgbClr val="1C2430"/>
                 </a:solidFill>
                 <a:latin typeface="Roboto"/>
               </a:rPr>
-              <a:t>Angular 19, 20… become routine</a:t>
+              <a:t/>
             </a:r>
           </a:p>
           <a:p>
             <a:pPr algn="l">
               <a:lnSpc>
-                <a:spcPct val="105000"/>
-              </a:lnSpc>
-              <a:spcAft>
-                <a:spcPts val="500"/>
-              </a:spcAft>
-            </a:pPr>
-            <a:r>
-              <a:rPr sz="1400" b="0" i="0">
-                <a:solidFill>
-                  <a:srgbClr val="1C2430"/>
-                </a:solidFill>
-                <a:latin typeface="Roboto"/>
-              </a:rPr>
-              <a:t>Same machinery: cloud migration, test coverage</a:t>
-            </a:r>
-          </a:p>
-        </p:txBody>
-      </p:sp>
-      <p:sp>
-        <p:nvSpPr>
-          <p:cNvPr id="19" name="Rounded Rectangle 18"/>
-          <p:cNvSpPr/>
-          <p:nvPr/>
-        </p:nvSpPr>
-        <p:spPr>
-          <a:xfrm>
-            <a:off x="502920" y="4023360"/>
-            <a:ext cx="11201400" cy="1051560"/>
-          </a:xfrm>
-          <a:prstGeom prst="roundRect">
-            <a:avLst>
-              <a:gd name="adj" fmla="val 10000"/>
-            </a:avLst>
-          </a:prstGeom>
-          <a:solidFill>
-            <a:srgbClr val="F4F6F9"/>
-          </a:solidFill>
-          <a:ln>
-            <a:noFill/>
-          </a:ln>
-          <a:effectLst/>
-        </p:spPr>
-        <p:style>
-          <a:lnRef idx="1">
-            <a:schemeClr val="accent1"/>
-          </a:lnRef>
-          <a:fillRef idx="3">
-            <a:schemeClr val="accent1"/>
-          </a:fillRef>
-          <a:effectRef idx="2">
-            <a:schemeClr val="accent1"/>
-          </a:effectRef>
-          <a:fontRef idx="minor">
-            <a:schemeClr val="lt1"/>
-          </a:fontRef>
-        </p:style>
-        <p:txBody>
-          <a:bodyPr rtlCol="0" anchor="ctr"/>
-          <a:lstStyle/>
-          <a:p>
-            <a:pPr algn="ctr"/>
-          </a:p>
-        </p:txBody>
-      </p:sp>
-      <p:sp>
-        <p:nvSpPr>
-          <p:cNvPr id="20" name="TextBox 19"/>
-          <p:cNvSpPr txBox="1"/>
-          <p:nvPr/>
-        </p:nvSpPr>
-        <p:spPr>
-          <a:xfrm>
-            <a:off x="777240" y="4224528"/>
-            <a:ext cx="10698480" cy="777240"/>
-          </a:xfrm>
-          <a:prstGeom prst="rect">
-            <a:avLst/>
-          </a:prstGeom>
-          <a:noFill/>
-        </p:spPr>
-        <p:txBody>
-          <a:bodyPr wrap="square" anchor="t">
-            <a:spAutoFit/>
-          </a:bodyPr>
-          <a:lstStyle/>
-          <a:p>
-            <a:pPr algn="l">
-              <a:lnSpc>
                 <a:spcPct val="100000"/>
               </a:lnSpc>
               <a:spcAft>
@@ -6194,20 +6040,20 @@
               </a:spcAft>
             </a:pPr>
             <a:r>
-              <a:rPr sz="1700" b="1" i="1">
-                <a:solidFill>
-                  <a:srgbClr val="012169"/>
-                </a:solidFill>
-                <a:latin typeface="Roboto"/>
-              </a:rPr>
-              <a:t>“We met a hard compliance deadline without pausing the roadmap.”</a:t>
-            </a:r>
-          </a:p>
-        </p:txBody>
-      </p:sp>
-      <p:sp>
-        <p:nvSpPr>
-          <p:cNvPr id="21" name="TextBox 20"/>
+              <a:rPr sz="1500" b="0" i="0">
+                <a:solidFill>
+                  <a:srgbClr val="FFFFFF"/>
+                </a:solidFill>
+                <a:latin typeface="Roboto"/>
+              </a:rPr>
+              <a:t>Every change reviewed, logged, and auditable</a:t>
+            </a:r>
+          </a:p>
+        </p:txBody>
+      </p:sp>
+      <p:sp>
+        <p:nvSpPr>
+          <p:cNvPr id="14" name="TextBox 13"/>
           <p:cNvSpPr txBox="1"/>
           <p:nvPr/>
         </p:nvSpPr>
@@ -7160,7 +7006,7 @@
                 </a:solidFill>
                 <a:latin typeface="Roboto"/>
               </a:rPr>
-              <a:t>See how it does</a:t>
+              <a:t>Assess pilot performance</a:t>
             </a:r>
           </a:p>
           <a:p>
@@ -7179,7 +7025,7 @@
                 </a:solidFill>
                 <a:latin typeface="Roboto"/>
               </a:rPr>
-              <a:t>Readout against your success criteria, in front of this room</a:t>
+              <a:t>Speed · engineer time saved · quality — against your targets</a:t>
             </a:r>
           </a:p>
         </p:txBody>
@@ -7414,7 +7260,7 @@
                 </a:solidFill>
                 <a:latin typeface="Roboto"/>
               </a:rPr>
-              <a:t>Rest of the Angular estate in parallel — then the broader maintenance backlog</a:t>
+              <a:t>If the pilot succeeds, we modernize the rest of your Angular estate in parallel</a:t>
             </a:r>
           </a:p>
         </p:txBody>

</xml_diff>